<commit_message>
feat: redesign examples with Korean editorial system
</commit_message>
<xml_diff>
--- a/examples/product_hype_reel.pptx
+++ b/examples/product_hype_reel.pptx
@@ -3586,7 +3586,7 @@
         <p:spPr>
           <a:xfrm>
             <a:off x="914400" y="2762250"/>
-            <a:ext cx="1657350" cy="323850"/>
+            <a:ext cx="1685925" cy="323850"/>
           </a:xfrm>
           <a:prstGeom prst="rect">
             <a:avLst/>
@@ -3607,7 +3607,7 @@
                 </a:solidFill>
                 <a:latin typeface="Roboto"/>
               </a:rPr>
-              <a:t>PULSE</a:t>
+              <a:t>GYEOL</a:t>
             </a:r>
           </a:p>
         </p:txBody>
@@ -3695,7 +3695,7 @@
         <p:spPr>
           <a:xfrm>
             <a:off x="914400" y="4762500"/>
-            <a:ext cx="4867275" cy="2371725"/>
+            <a:ext cx="5572125" cy="1924050"/>
           </a:xfrm>
           <a:prstGeom prst="rect">
             <a:avLst/>
@@ -3710,49 +3710,33 @@
           <a:p>
             <a:pPr algn="l">
               <a:lnSpc>
-                <a:spcPts val="6750"/>
+                <a:spcPts val="7725"/>
               </a:lnSpc>
             </a:pPr>
             <a:r>
-              <a:rPr sz="7125" b="0" i="0">
+              <a:rPr sz="8100" b="0" i="0">
                 <a:solidFill>
                   <a:srgbClr val="FFFFFF"/>
                 </a:solidFill>
                 <a:latin typeface="Pretendard"/>
               </a:rPr>
-              <a:t>TRAINING,</a:t>
+              <a:t>내 몸의 리듬을</a:t>
             </a:r>
           </a:p>
           <a:p>
             <a:pPr algn="l">
               <a:lnSpc>
-                <a:spcPts val="6750"/>
+                <a:spcPts val="7725"/>
               </a:lnSpc>
             </a:pPr>
             <a:r>
-              <a:rPr sz="7125" b="0" i="0">
+              <a:rPr sz="8100" b="0" i="0">
                 <a:solidFill>
                   <a:srgbClr val="FFFFFF"/>
                 </a:solidFill>
                 <a:latin typeface="Pretendard"/>
               </a:rPr>
-              <a:t>MADE</a:t>
-            </a:r>
-          </a:p>
-          <a:p>
-            <a:pPr algn="l">
-              <a:lnSpc>
-                <a:spcPts val="6750"/>
-              </a:lnSpc>
-            </a:pPr>
-            <a:r>
-              <a:rPr sz="7125" b="0" i="0">
-                <a:solidFill>
-                  <a:srgbClr val="FFFFFF"/>
-                </a:solidFill>
-                <a:latin typeface="Pretendard"/>
-              </a:rPr>
-              <a:t>PERSONAL.</a:t>
+              <a:t>다시 만나다.</a:t>
             </a:r>
           </a:p>
         </p:txBody>
@@ -3766,7 +3750,7 @@
         <p:spPr>
           <a:xfrm>
             <a:off x="914400" y="7667625"/>
-            <a:ext cx="7248525" cy="1066800"/>
+            <a:ext cx="7486650" cy="1047750"/>
           </a:xfrm>
           <a:prstGeom prst="rect">
             <a:avLst/>
@@ -3791,7 +3775,7 @@
                 </a:solidFill>
                 <a:latin typeface="Pretendard"/>
               </a:rPr>
-              <a:t>From heart rate to recovery, see</a:t>
+              <a:t>심박부터 회복까지, 오늘의 몸을 한눈에</a:t>
             </a:r>
           </a:p>
           <a:p>
@@ -3807,7 +3791,7 @@
                 </a:solidFill>
                 <a:latin typeface="Pretendard"/>
               </a:rPr>
-              <a:t>your rhythm at a glance.</a:t>
+              <a:t>읽습니다.</a:t>
             </a:r>
           </a:p>
         </p:txBody>
@@ -3875,7 +3859,7 @@
         <p:spPr>
           <a:xfrm>
             <a:off x="1371600" y="9696450"/>
-            <a:ext cx="4514850" cy="371475"/>
+            <a:ext cx="2686050" cy="419100"/>
           </a:xfrm>
           <a:prstGeom prst="rect">
             <a:avLst/>
@@ -3896,7 +3880,7 @@
                 </a:solidFill>
                 <a:latin typeface="Pretendard"/>
               </a:rPr>
-              <a:t>●  LIVE HEART RATE</a:t>
+              <a:t>●  실시간 심박</a:t>
             </a:r>
           </a:p>
         </p:txBody>
@@ -3909,8 +3893,8 @@
         </p:nvSpPr>
         <p:spPr>
           <a:xfrm>
-            <a:off x="6438900" y="9696450"/>
-            <a:ext cx="1638300" cy="323850"/>
+            <a:off x="6886575" y="9696450"/>
+            <a:ext cx="1190625" cy="419100"/>
           </a:xfrm>
           <a:prstGeom prst="rect">
             <a:avLst/>
@@ -3931,7 +3915,7 @@
                 </a:solidFill>
                 <a:latin typeface="Pretendard"/>
               </a:rPr>
-              <a:t>ZONE 4</a:t>
+              <a:t>구간 4</a:t>
             </a:r>
           </a:p>
         </p:txBody>
@@ -4022,7 +4006,7 @@
         <p:spPr>
           <a:xfrm>
             <a:off x="1371600" y="12763500"/>
-            <a:ext cx="6515100" cy="323850"/>
+            <a:ext cx="3429000" cy="409575"/>
           </a:xfrm>
           <a:prstGeom prst="rect">
             <a:avLst/>
@@ -4043,7 +4027,7 @@
                 </a:solidFill>
                 <a:latin typeface="Pretendard"/>
               </a:rPr>
-              <a:t>HEART RATE  ·  PERFORMANCE</a:t>
+              <a:t>심박수  ·  운동 강도</a:t>
             </a:r>
           </a:p>
         </p:txBody>
@@ -4057,7 +4041,7 @@
         <p:spPr>
           <a:xfrm>
             <a:off x="914400" y="14249400"/>
-            <a:ext cx="6877050" cy="323850"/>
+            <a:ext cx="5934075" cy="419100"/>
           </a:xfrm>
           <a:prstGeom prst="rect">
             <a:avLst/>
@@ -4082,7 +4066,7 @@
                 </a:solidFill>
                 <a:latin typeface="Pretendard"/>
               </a:rPr>
-              <a:t>PULSE · PERSONAL FITNESS OS</a:t>
+              <a:t>GYEOL · 나를 읽는 피트니스 OS</a:t>
             </a:r>
           </a:p>
         </p:txBody>
@@ -5186,7 +5170,7 @@
         <p:spPr>
           <a:xfrm>
             <a:off x="914400" y="2762250"/>
-            <a:ext cx="1657350" cy="323850"/>
+            <a:ext cx="1685925" cy="323850"/>
           </a:xfrm>
           <a:prstGeom prst="rect">
             <a:avLst/>
@@ -5207,7 +5191,7 @@
                 </a:solidFill>
                 <a:latin typeface="Roboto"/>
               </a:rPr>
-              <a:t>PULSE</a:t>
+              <a:t>GYEOL</a:t>
             </a:r>
           </a:p>
         </p:txBody>
@@ -5256,7 +5240,7 @@
         <p:spPr>
           <a:xfrm>
             <a:off x="914400" y="3905250"/>
-            <a:ext cx="3390900" cy="323850"/>
+            <a:ext cx="2562225" cy="428625"/>
           </a:xfrm>
           <a:prstGeom prst="rect">
             <a:avLst/>
@@ -5281,7 +5265,7 @@
                 </a:solidFill>
                 <a:latin typeface="Pretendard"/>
               </a:rPr>
-              <a:t>THE PROBLEM</a:t>
+              <a:t>꾸준함의 조건</a:t>
             </a:r>
           </a:p>
         </p:txBody>
@@ -5295,7 +5279,7 @@
         <p:spPr>
           <a:xfrm>
             <a:off x="914400" y="4762500"/>
-            <a:ext cx="6286500" cy="2371725"/>
+            <a:ext cx="4772025" cy="1704975"/>
           </a:xfrm>
           <a:prstGeom prst="rect">
             <a:avLst/>
@@ -5310,49 +5294,33 @@
           <a:p>
             <a:pPr algn="l">
               <a:lnSpc>
-                <a:spcPts val="6750"/>
+                <a:spcPts val="6825"/>
               </a:lnSpc>
             </a:pPr>
             <a:r>
-              <a:rPr sz="7125" b="0" i="0">
+              <a:rPr sz="7200" b="0" i="0">
                 <a:solidFill>
                   <a:srgbClr val="FFFFFF"/>
                 </a:solidFill>
                 <a:latin typeface="Pretendard"/>
               </a:rPr>
-              <a:t>CONSISTENCY</a:t>
+              <a:t>의지보다 먼저</a:t>
             </a:r>
           </a:p>
           <a:p>
             <a:pPr algn="l">
               <a:lnSpc>
-                <a:spcPts val="6750"/>
+                <a:spcPts val="6825"/>
               </a:lnSpc>
             </a:pPr>
             <a:r>
-              <a:rPr sz="7125" b="0" i="0">
+              <a:rPr sz="7200" b="0" i="0">
                 <a:solidFill>
                   <a:srgbClr val="FFFFFF"/>
                 </a:solidFill>
                 <a:latin typeface="Pretendard"/>
               </a:rPr>
-              <a:t>NEEDS A</a:t>
-            </a:r>
-          </a:p>
-          <a:p>
-            <a:pPr algn="l">
-              <a:lnSpc>
-                <a:spcPts val="6750"/>
-              </a:lnSpc>
-            </a:pPr>
-            <a:r>
-              <a:rPr sz="7125" b="0" i="0">
-                <a:solidFill>
-                  <a:srgbClr val="FFFFFF"/>
-                </a:solidFill>
-                <a:latin typeface="Pretendard"/>
-              </a:rPr>
-              <a:t>SYSTEM.</a:t>
+              <a:t>필요한 것.</a:t>
             </a:r>
           </a:p>
         </p:txBody>
@@ -5366,7 +5334,7 @@
         <p:spPr>
           <a:xfrm>
             <a:off x="914400" y="7667625"/>
-            <a:ext cx="6286500" cy="981075"/>
+            <a:ext cx="5514975" cy="1047750"/>
           </a:xfrm>
           <a:prstGeom prst="rect">
             <a:avLst/>
@@ -5391,7 +5359,7 @@
                 </a:solidFill>
                 <a:latin typeface="Pretendard"/>
               </a:rPr>
-              <a:t>When feedback arrives late,</a:t>
+              <a:t>피드백이 늦으면 마음도 금세</a:t>
             </a:r>
           </a:p>
           <a:p>
@@ -5407,7 +5375,7 @@
                 </a:solidFill>
                 <a:latin typeface="Pretendard"/>
               </a:rPr>
-              <a:t>motivation follows.</a:t>
+              <a:t>멀어집니다.</a:t>
             </a:r>
           </a:p>
         </p:txBody>
@@ -5475,7 +5443,7 @@
         <p:spPr>
           <a:xfrm>
             <a:off x="1333500" y="9858375"/>
-            <a:ext cx="4543425" cy="323850"/>
+            <a:ext cx="2552700" cy="419100"/>
           </a:xfrm>
           <a:prstGeom prst="rect">
             <a:avLst/>
@@ -5496,7 +5464,7 @@
                 </a:solidFill>
                 <a:latin typeface="Pretendard"/>
               </a:rPr>
-              <a:t>AVERAGE DROP-OFF</a:t>
+              <a:t>평균 이탈 시점</a:t>
             </a:r>
           </a:p>
         </p:txBody>
@@ -5509,8 +5477,8 @@
         </p:nvSpPr>
         <p:spPr>
           <a:xfrm>
-            <a:off x="5105400" y="10258425"/>
-            <a:ext cx="2971800" cy="571500"/>
+            <a:off x="6219825" y="10258425"/>
+            <a:ext cx="1857375" cy="714375"/>
           </a:xfrm>
           <a:prstGeom prst="rect">
             <a:avLst/>
@@ -5531,7 +5499,7 @@
                 </a:solidFill>
                 <a:latin typeface="Pretendard"/>
               </a:rPr>
-              <a:t>DAY 03</a:t>
+              <a:t>3일째</a:t>
             </a:r>
           </a:p>
         </p:txBody>
@@ -5599,7 +5567,7 @@
         <p:spPr>
           <a:xfrm>
             <a:off x="1333500" y="11953875"/>
-            <a:ext cx="3457575" cy="323850"/>
+            <a:ext cx="2447925" cy="419100"/>
           </a:xfrm>
           <a:prstGeom prst="rect">
             <a:avLst/>
@@ -5620,7 +5588,7 @@
                 </a:solidFill>
                 <a:latin typeface="Pretendard"/>
               </a:rPr>
-              <a:t>LIVE FEEDBACK</a:t>
+              <a:t>실시간 피드백</a:t>
             </a:r>
           </a:p>
         </p:txBody>
@@ -5669,7 +5637,7 @@
         <p:spPr>
           <a:xfrm>
             <a:off x="914400" y="14249400"/>
-            <a:ext cx="4962525" cy="819150"/>
+            <a:ext cx="6800850" cy="419100"/>
           </a:xfrm>
           <a:prstGeom prst="rect">
             <a:avLst/>
@@ -5694,23 +5662,7 @@
                 </a:solidFill>
                 <a:latin typeface="Pretendard"/>
               </a:rPr>
-              <a:t>LATE FEEDBACK KILLS</a:t>
-            </a:r>
-          </a:p>
-          <a:p>
-            <a:pPr algn="l">
-              <a:lnSpc>
-                <a:spcPts val="3900"/>
-              </a:lnSpc>
-            </a:pPr>
-            <a:r>
-              <a:rPr sz="3600" b="0" i="0">
-                <a:solidFill>
-                  <a:srgbClr val="F8F4FF"/>
-                </a:solidFill>
-                <a:latin typeface="Pretendard"/>
-              </a:rPr>
-              <a:t>MOMENTUM.</a:t>
+              <a:t>늦은 피드백은 움직일 마음을 놓칩니다.</a:t>
             </a:r>
           </a:p>
         </p:txBody>
@@ -6814,7 +6766,7 @@
         <p:spPr>
           <a:xfrm>
             <a:off x="914400" y="2762250"/>
-            <a:ext cx="1657350" cy="323850"/>
+            <a:ext cx="1685925" cy="323850"/>
           </a:xfrm>
           <a:prstGeom prst="rect">
             <a:avLst/>
@@ -6835,7 +6787,7 @@
                 </a:solidFill>
                 <a:latin typeface="Roboto"/>
               </a:rPr>
-              <a:t>PULSE</a:t>
+              <a:t>GYEOL</a:t>
             </a:r>
           </a:p>
         </p:txBody>
@@ -6884,7 +6836,7 @@
         <p:spPr>
           <a:xfrm>
             <a:off x="914400" y="3905250"/>
-            <a:ext cx="3000375" cy="323850"/>
+            <a:ext cx="3076575" cy="323850"/>
           </a:xfrm>
           <a:prstGeom prst="rect">
             <a:avLst/>
@@ -6909,7 +6861,7 @@
                 </a:solidFill>
                 <a:latin typeface="Pretendard"/>
               </a:rPr>
-              <a:t>MEET PULSE</a:t>
+              <a:t>MEET GYEOL</a:t>
             </a:r>
           </a:p>
         </p:txBody>
@@ -6923,7 +6875,7 @@
         <p:spPr>
           <a:xfrm>
             <a:off x="914400" y="4762500"/>
-            <a:ext cx="7543800" cy="1571625"/>
+            <a:ext cx="6734175" cy="1924050"/>
           </a:xfrm>
           <a:prstGeom prst="rect">
             <a:avLst/>
@@ -6938,33 +6890,33 @@
           <a:p>
             <a:pPr algn="l">
               <a:lnSpc>
-                <a:spcPts val="7050"/>
+                <a:spcPts val="7725"/>
               </a:lnSpc>
             </a:pPr>
             <a:r>
-              <a:rPr sz="7425" b="0" i="0">
+              <a:rPr sz="8100" b="0" i="0">
                 <a:solidFill>
                   <a:srgbClr val="FFFFFF"/>
                 </a:solidFill>
                 <a:latin typeface="Pretendard"/>
               </a:rPr>
-              <a:t>FIND YOUR</a:t>
+              <a:t>흩어진 신호가</a:t>
             </a:r>
           </a:p>
           <a:p>
             <a:pPr algn="l">
               <a:lnSpc>
-                <a:spcPts val="7050"/>
+                <a:spcPts val="7725"/>
               </a:lnSpc>
             </a:pPr>
             <a:r>
-              <a:rPr sz="7425" b="0" i="0">
+              <a:rPr sz="8100" b="0" i="0">
                 <a:solidFill>
                   <a:srgbClr val="FFFFFF"/>
                 </a:solidFill>
                 <a:latin typeface="Pretendard"/>
               </a:rPr>
-              <a:t>DAILY RHYTHM.</a:t>
+              <a:t>하나의 리듬으로.</a:t>
             </a:r>
           </a:p>
         </p:txBody>
@@ -6978,7 +6930,7 @@
         <p:spPr>
           <a:xfrm>
             <a:off x="914400" y="7667625"/>
-            <a:ext cx="6953250" cy="1057275"/>
+            <a:ext cx="6496050" cy="1038225"/>
           </a:xfrm>
           <a:prstGeom prst="rect">
             <a:avLst/>
@@ -7003,7 +6955,7 @@
                 </a:solidFill>
                 <a:latin typeface="Pretendard"/>
               </a:rPr>
-              <a:t>Turn scattered signals into one</a:t>
+              <a:t>복잡한 몸의 신호를 오늘의 점수로</a:t>
             </a:r>
           </a:p>
           <a:p>
@@ -7019,7 +6971,7 @@
                 </a:solidFill>
                 <a:latin typeface="Pretendard"/>
               </a:rPr>
-              <a:t>clear daily score.</a:t>
+              <a:t>바꿉니다.</a:t>
             </a:r>
           </a:p>
         </p:txBody>
@@ -7087,7 +7039,7 @@
         <p:spPr>
           <a:xfrm>
             <a:off x="1371600" y="9696450"/>
-            <a:ext cx="2428875" cy="323850"/>
+            <a:ext cx="1666875" cy="419100"/>
           </a:xfrm>
           <a:prstGeom prst="rect">
             <a:avLst/>
@@ -7108,7 +7060,7 @@
                 </a:solidFill>
                 <a:latin typeface="Pretendard"/>
               </a:rPr>
-              <a:t>RECOVERY</a:t>
+              <a:t>회복 점수</a:t>
             </a:r>
           </a:p>
         </p:txBody>
@@ -7199,7 +7151,7 @@
         <p:spPr>
           <a:xfrm>
             <a:off x="1371600" y="12192000"/>
-            <a:ext cx="5019675" cy="790575"/>
+            <a:ext cx="3819525" cy="857250"/>
           </a:xfrm>
           <a:prstGeom prst="rect">
             <a:avLst/>
@@ -7224,7 +7176,7 @@
                 </a:solidFill>
                 <a:latin typeface="Pretendard"/>
               </a:rPr>
-              <a:t>SLEEP 92 · ENERGY 81</a:t>
+              <a:t>수면 92 · 에너지 81</a:t>
             </a:r>
           </a:p>
           <a:p>
@@ -7240,7 +7192,7 @@
                 </a:solidFill>
                 <a:latin typeface="Pretendard"/>
               </a:rPr>
-              <a:t>STRESS 24</a:t>
+              <a:t>스트레스 24</a:t>
             </a:r>
           </a:p>
         </p:txBody>
@@ -7254,7 +7206,7 @@
         <p:spPr>
           <a:xfrm>
             <a:off x="914400" y="14249400"/>
-            <a:ext cx="5848350" cy="819150"/>
+            <a:ext cx="5524500" cy="419100"/>
           </a:xfrm>
           <a:prstGeom prst="rect">
             <a:avLst/>
@@ -7279,23 +7231,7 @@
                 </a:solidFill>
                 <a:latin typeface="Pretendard"/>
               </a:rPr>
-              <a:t>READ TODAY'S BODY AT A</a:t>
-            </a:r>
-          </a:p>
-          <a:p>
-            <a:pPr algn="l">
-              <a:lnSpc>
-                <a:spcPts val="3900"/>
-              </a:lnSpc>
-            </a:pPr>
-            <a:r>
-              <a:rPr sz="3600" b="0" i="0">
-                <a:solidFill>
-                  <a:srgbClr val="F8F4FF"/>
-                </a:solidFill>
-                <a:latin typeface="Pretendard"/>
-              </a:rPr>
-              <a:t>GLANCE.</a:t>
+              <a:t>오늘의 몸을 한눈에 읽어보세요.</a:t>
             </a:r>
           </a:p>
         </p:txBody>
@@ -8346,7 +8282,7 @@
         <p:spPr>
           <a:xfrm>
             <a:off x="914400" y="2762250"/>
-            <a:ext cx="1657350" cy="323850"/>
+            <a:ext cx="1685925" cy="323850"/>
           </a:xfrm>
           <a:prstGeom prst="rect">
             <a:avLst/>
@@ -8367,7 +8303,7 @@
                 </a:solidFill>
                 <a:latin typeface="Roboto"/>
               </a:rPr>
-              <a:t>PULSE</a:t>
+              <a:t>GYEOL</a:t>
             </a:r>
           </a:p>
         </p:txBody>
@@ -8455,7 +8391,7 @@
         <p:spPr>
           <a:xfrm>
             <a:off x="914400" y="4762500"/>
-            <a:ext cx="5295900" cy="1485900"/>
+            <a:ext cx="5524500" cy="1647825"/>
           </a:xfrm>
           <a:prstGeom prst="rect">
             <a:avLst/>
@@ -8480,7 +8416,7 @@
                 </a:solidFill>
                 <a:latin typeface="Pretendard"/>
               </a:rPr>
-              <a:t>NEVER MISS</a:t>
+              <a:t>움직이는 순간을</a:t>
             </a:r>
           </a:p>
           <a:p>
@@ -8496,7 +8432,7 @@
                 </a:solidFill>
                 <a:latin typeface="Pretendard"/>
               </a:rPr>
-              <a:t>A BEAT.</a:t>
+              <a:t>놓치지 않게.</a:t>
             </a:r>
           </a:p>
         </p:txBody>
@@ -8510,7 +8446,7 @@
         <p:spPr>
           <a:xfrm>
             <a:off x="914400" y="7667625"/>
-            <a:ext cx="6115050" cy="1057275"/>
+            <a:ext cx="6924675" cy="1047750"/>
           </a:xfrm>
           <a:prstGeom prst="rect">
             <a:avLst/>
@@ -8535,7 +8471,7 @@
                 </a:solidFill>
                 <a:latin typeface="Pretendard"/>
               </a:rPr>
-              <a:t>Track heart-rate zones and</a:t>
+              <a:t>심박 구간과 운동 강도를 실시간으로</a:t>
             </a:r>
           </a:p>
           <a:p>
@@ -8551,7 +8487,7 @@
                 </a:solidFill>
                 <a:latin typeface="Pretendard"/>
               </a:rPr>
-              <a:t>workout intensity live.</a:t>
+              <a:t>읽습니다.</a:t>
             </a:r>
           </a:p>
         </p:txBody>
@@ -8619,7 +8555,7 @@
         <p:spPr>
           <a:xfrm>
             <a:off x="1371600" y="9696450"/>
-            <a:ext cx="3895725" cy="323850"/>
+            <a:ext cx="2066925" cy="419100"/>
           </a:xfrm>
           <a:prstGeom prst="rect">
             <a:avLst/>
@@ -8640,7 +8576,7 @@
                 </a:solidFill>
                 <a:latin typeface="Pretendard"/>
               </a:rPr>
-              <a:t>LIVE HEART RATE</a:t>
+              <a:t>실시간 심박</a:t>
             </a:r>
           </a:p>
         </p:txBody>
@@ -8766,7 +8702,7 @@
         <p:spPr>
           <a:xfrm>
             <a:off x="1371600" y="12192000"/>
-            <a:ext cx="6667500" cy="333375"/>
+            <a:ext cx="4724400" cy="419100"/>
           </a:xfrm>
           <a:prstGeom prst="rect">
             <a:avLst/>
@@ -8791,7 +8727,7 @@
                 </a:solidFill>
                 <a:latin typeface="Pretendard"/>
               </a:rPr>
-              <a:t>WARM-UP · FAT BURN · CARDIO</a:t>
+              <a:t>워밍업 · 지방 연소 · 유산소</a:t>
             </a:r>
           </a:p>
         </p:txBody>
@@ -8805,7 +8741,7 @@
         <p:spPr>
           <a:xfrm>
             <a:off x="914400" y="14249400"/>
-            <a:ext cx="7315200" cy="323850"/>
+            <a:ext cx="7315200" cy="914400"/>
           </a:xfrm>
           <a:prstGeom prst="rect">
             <a:avLst/>
@@ -8831,6 +8767,22 @@
                 <a:latin typeface="Pretendard"/>
               </a:rPr>
               <a:t>APPLE WATCH · GALAXY WATCH</a:t>
+            </a:r>
+          </a:p>
+          <a:p>
+            <a:pPr algn="l">
+              <a:lnSpc>
+                <a:spcPts val="3900"/>
+              </a:lnSpc>
+            </a:pPr>
+            <a:r>
+              <a:rPr sz="3600" b="0" i="0">
+                <a:solidFill>
+                  <a:srgbClr val="F8F4FF"/>
+                </a:solidFill>
+                <a:latin typeface="Pretendard"/>
+              </a:rPr>
+              <a:t>연동</a:t>
             </a:r>
           </a:p>
         </p:txBody>
@@ -9934,7 +9886,7 @@
         <p:spPr>
           <a:xfrm>
             <a:off x="914400" y="2762250"/>
-            <a:ext cx="1657350" cy="323850"/>
+            <a:ext cx="1685925" cy="323850"/>
           </a:xfrm>
           <a:prstGeom prst="rect">
             <a:avLst/>
@@ -9955,7 +9907,7 @@
                 </a:solidFill>
                 <a:latin typeface="Roboto"/>
               </a:rPr>
-              <a:t>PULSE</a:t>
+              <a:t>GYEOL</a:t>
             </a:r>
           </a:p>
         </p:txBody>
@@ -10043,7 +9995,7 @@
         <p:spPr>
           <a:xfrm>
             <a:off x="914400" y="4762500"/>
-            <a:ext cx="7038975" cy="1514475"/>
+            <a:ext cx="5153025" cy="1685925"/>
           </a:xfrm>
           <a:prstGeom prst="rect">
             <a:avLst/>
@@ -10068,7 +10020,7 @@
                 </a:solidFill>
                 <a:latin typeface="Pretendard"/>
               </a:rPr>
-              <a:t>AI SETS</a:t>
+              <a:t>오늘의 속도는</a:t>
             </a:r>
           </a:p>
           <a:p>
@@ -10084,7 +10036,7 @@
                 </a:solidFill>
                 <a:latin typeface="Pretendard"/>
               </a:rPr>
-              <a:t>TODAY'S PACE.</a:t>
+              <a:t>몸이 정하니까.</a:t>
             </a:r>
           </a:p>
         </p:txBody>
@@ -10098,7 +10050,7 @@
         <p:spPr>
           <a:xfrm>
             <a:off x="914400" y="7667625"/>
-            <a:ext cx="6962775" cy="962025"/>
+            <a:ext cx="6067425" cy="1047750"/>
           </a:xfrm>
           <a:prstGeom prst="rect">
             <a:avLst/>
@@ -10123,7 +10075,7 @@
                 </a:solidFill>
                 <a:latin typeface="Pretendard"/>
               </a:rPr>
-              <a:t>Adapt duration and intensity to</a:t>
+              <a:t>회복 상태에 맞춰 시간과 강도를</a:t>
             </a:r>
           </a:p>
           <a:p>
@@ -10139,7 +10091,7 @@
                 </a:solidFill>
                 <a:latin typeface="Pretendard"/>
               </a:rPr>
-              <a:t>your recovery.</a:t>
+              <a:t>조정합니다.</a:t>
             </a:r>
           </a:p>
         </p:txBody>
@@ -10207,7 +10159,7 @@
         <p:spPr>
           <a:xfrm>
             <a:off x="1371600" y="9696450"/>
-            <a:ext cx="3333750" cy="323850"/>
+            <a:ext cx="2447925" cy="419100"/>
           </a:xfrm>
           <a:prstGeom prst="rect">
             <a:avLst/>
@@ -10228,7 +10180,7 @@
                 </a:solidFill>
                 <a:latin typeface="Pretendard"/>
               </a:rPr>
-              <a:t>TODAY'S LOAD</a:t>
+              <a:t>오늘의 운동량</a:t>
             </a:r>
           </a:p>
         </p:txBody>
@@ -10393,7 +10345,7 @@
         <p:spPr>
           <a:xfrm>
             <a:off x="914400" y="14249400"/>
-            <a:ext cx="7477125" cy="819150"/>
+            <a:ext cx="5629275" cy="419100"/>
           </a:xfrm>
           <a:prstGeom prst="rect">
             <a:avLst/>
@@ -10418,23 +10370,7 @@
                 </a:solidFill>
                 <a:latin typeface="Pretendard"/>
               </a:rPr>
-              <a:t>A COACHING PLAN THAT ADAPTS</a:t>
-            </a:r>
-          </a:p>
-          <a:p>
-            <a:pPr algn="l">
-              <a:lnSpc>
-                <a:spcPts val="3900"/>
-              </a:lnSpc>
-            </a:pPr>
-            <a:r>
-              <a:rPr sz="3600" b="0" i="0">
-                <a:solidFill>
-                  <a:srgbClr val="F8F4FF"/>
-                </a:solidFill>
-                <a:latin typeface="Pretendard"/>
-              </a:rPr>
-              <a:t>EVERY DAY.</a:t>
+              <a:t>매일 달라지는 나에게 맞춘 코칭.</a:t>
             </a:r>
           </a:p>
         </p:txBody>
@@ -11538,7 +11474,7 @@
         <p:spPr>
           <a:xfrm>
             <a:off x="914400" y="2762250"/>
-            <a:ext cx="1657350" cy="323850"/>
+            <a:ext cx="1685925" cy="323850"/>
           </a:xfrm>
           <a:prstGeom prst="rect">
             <a:avLst/>
@@ -11559,7 +11495,7 @@
                 </a:solidFill>
                 <a:latin typeface="Roboto"/>
               </a:rPr>
-              <a:t>PULSE</a:t>
+              <a:t>GYEOL</a:t>
             </a:r>
           </a:p>
         </p:txBody>
@@ -11647,7 +11583,7 @@
         <p:spPr>
           <a:xfrm>
             <a:off x="914400" y="4762500"/>
-            <a:ext cx="7600950" cy="2286000"/>
+            <a:ext cx="6543675" cy="1704975"/>
           </a:xfrm>
           <a:prstGeom prst="rect">
             <a:avLst/>
@@ -11662,49 +11598,33 @@
           <a:p>
             <a:pPr algn="l">
               <a:lnSpc>
-                <a:spcPts val="6525"/>
+                <a:spcPts val="6825"/>
               </a:lnSpc>
             </a:pPr>
             <a:r>
-              <a:rPr sz="6825" b="0" i="0">
+              <a:rPr sz="7200" b="0" i="0">
                 <a:solidFill>
                   <a:srgbClr val="FFFFFF"/>
                 </a:solidFill>
                 <a:latin typeface="Pretendard"/>
               </a:rPr>
-              <a:t>TURN THREE DAYS</a:t>
+              <a:t>작은 사흘이</a:t>
             </a:r>
           </a:p>
           <a:p>
             <a:pPr algn="l">
               <a:lnSpc>
-                <a:spcPts val="6525"/>
+                <a:spcPts val="6825"/>
               </a:lnSpc>
             </a:pPr>
             <a:r>
-              <a:rPr sz="6825" b="0" i="0">
+              <a:rPr sz="7200" b="0" i="0">
                 <a:solidFill>
                   <a:srgbClr val="FFFFFF"/>
                 </a:solidFill>
                 <a:latin typeface="Pretendard"/>
               </a:rPr>
-              <a:t>INTO</a:t>
-            </a:r>
-          </a:p>
-          <a:p>
-            <a:pPr algn="l">
-              <a:lnSpc>
-                <a:spcPts val="6525"/>
-              </a:lnSpc>
-            </a:pPr>
-            <a:r>
-              <a:rPr sz="6825" b="0" i="0">
-                <a:solidFill>
-                  <a:srgbClr val="FFFFFF"/>
-                </a:solidFill>
-                <a:latin typeface="Pretendard"/>
-              </a:rPr>
-              <a:t>TWENTY-ONE.</a:t>
+              <a:t>스물하루가 되도록.</a:t>
             </a:r>
           </a:p>
         </p:txBody>
@@ -11718,7 +11638,7 @@
         <p:spPr>
           <a:xfrm>
             <a:off x="914400" y="7667625"/>
-            <a:ext cx="7029450" cy="962025"/>
+            <a:ext cx="5943600" cy="1047750"/>
           </a:xfrm>
           <a:prstGeom prst="rect">
             <a:avLst/>
@@ -11743,7 +11663,7 @@
                 </a:solidFill>
                 <a:latin typeface="Pretendard"/>
               </a:rPr>
-              <a:t>Link small wins into a habit that</a:t>
+              <a:t>작은 성공을 오래가는 습관으로</a:t>
             </a:r>
           </a:p>
           <a:p>
@@ -11759,7 +11679,7 @@
                 </a:solidFill>
                 <a:latin typeface="Pretendard"/>
               </a:rPr>
-              <a:t>lasts.</a:t>
+              <a:t>연결합니다.</a:t>
             </a:r>
           </a:p>
         </p:txBody>
@@ -11827,7 +11747,7 @@
         <p:spPr>
           <a:xfrm>
             <a:off x="1371600" y="9696450"/>
-            <a:ext cx="3248025" cy="323850"/>
+            <a:ext cx="1171575" cy="409575"/>
           </a:xfrm>
           <a:prstGeom prst="rect">
             <a:avLst/>
@@ -11848,7 +11768,7 @@
                 </a:solidFill>
                 <a:latin typeface="Pretendard"/>
               </a:rPr>
-              <a:t>CONSISTENCY</a:t>
+              <a:t>꾸준함</a:t>
             </a:r>
           </a:p>
         </p:txBody>
@@ -11861,8 +11781,8 @@
         </p:nvSpPr>
         <p:spPr>
           <a:xfrm>
-            <a:off x="6905625" y="9696450"/>
-            <a:ext cx="1171575" cy="323850"/>
+            <a:off x="6410325" y="9696450"/>
+            <a:ext cx="1666875" cy="419100"/>
           </a:xfrm>
           <a:prstGeom prst="rect">
             <a:avLst/>
@@ -11883,7 +11803,7 @@
                 </a:solidFill>
                 <a:latin typeface="Pretendard"/>
               </a:rPr>
-              <a:t>BEST</a:t>
+              <a:t>최고 기록</a:t>
             </a:r>
           </a:p>
         </p:txBody>
@@ -11939,7 +11859,7 @@
         <p:spPr>
           <a:xfrm>
             <a:off x="4095750" y="11715750"/>
-            <a:ext cx="3162300" cy="371475"/>
+            <a:ext cx="1400175" cy="447675"/>
           </a:xfrm>
           <a:prstGeom prst="rect">
             <a:avLst/>
@@ -11960,7 +11880,7 @@
                 </a:solidFill>
                 <a:latin typeface="Pretendard"/>
               </a:rPr>
-              <a:t>DAY STREAK</a:t>
+              <a:t>일 연속</a:t>
             </a:r>
           </a:p>
         </p:txBody>
@@ -12009,7 +11929,7 @@
         <p:spPr>
           <a:xfrm>
             <a:off x="914400" y="14249400"/>
-            <a:ext cx="7191375" cy="819150"/>
+            <a:ext cx="6305550" cy="419100"/>
           </a:xfrm>
           <a:prstGeom prst="rect">
             <a:avLst/>
@@ -12034,23 +11954,7 @@
                 </a:solidFill>
                 <a:latin typeface="Pretendard"/>
               </a:rPr>
-              <a:t>WHEN CONSISTENCY IS VISIBLE,</a:t>
-            </a:r>
-          </a:p>
-          <a:p>
-            <a:pPr algn="l">
-              <a:lnSpc>
-                <a:spcPts val="3900"/>
-              </a:lnSpc>
-            </a:pPr>
-            <a:r>
-              <a:rPr sz="3600" b="0" i="0">
-                <a:solidFill>
-                  <a:srgbClr val="F8F4FF"/>
-                </a:solidFill>
-                <a:latin typeface="Pretendard"/>
-              </a:rPr>
-              <a:t>HABITS KEEP GOING.</a:t>
+              <a:t>꾸준함이 보이면 습관은 계속됩니다.</a:t>
             </a:r>
           </a:p>
         </p:txBody>
@@ -13154,7 +13058,7 @@
         <p:spPr>
           <a:xfrm>
             <a:off x="914400" y="2762250"/>
-            <a:ext cx="1657350" cy="323850"/>
+            <a:ext cx="1685925" cy="323850"/>
           </a:xfrm>
           <a:prstGeom prst="rect">
             <a:avLst/>
@@ -13175,7 +13079,7 @@
                 </a:solidFill>
                 <a:latin typeface="Roboto"/>
               </a:rPr>
-              <a:t>PULSE</a:t>
+              <a:t>GYEOL</a:t>
             </a:r>
           </a:p>
         </p:txBody>
@@ -13224,7 +13128,7 @@
         <p:spPr>
           <a:xfrm>
             <a:off x="914400" y="3905250"/>
-            <a:ext cx="4848225" cy="419100"/>
+            <a:ext cx="4267200" cy="466725"/>
           </a:xfrm>
           <a:prstGeom prst="rect">
             <a:avLst/>
@@ -13249,7 +13153,7 @@
                 </a:solidFill>
                 <a:latin typeface="Pretendard"/>
               </a:rPr>
-              <a:t>4.9 · 2,841 REVIEWS</a:t>
+              <a:t>4.9 · 2,841개의 기록</a:t>
             </a:r>
           </a:p>
         </p:txBody>
@@ -13263,7 +13167,7 @@
         <p:spPr>
           <a:xfrm>
             <a:off x="914400" y="4762500"/>
-            <a:ext cx="6067425" cy="1600200"/>
+            <a:ext cx="4610100" cy="1771650"/>
           </a:xfrm>
           <a:prstGeom prst="rect">
             <a:avLst/>
@@ -13288,7 +13192,7 @@
                 </a:solidFill>
                 <a:latin typeface="Pretendard"/>
               </a:rPr>
-              <a:t>GO LONGER.</a:t>
+              <a:t>조금 더 오래,</a:t>
             </a:r>
           </a:p>
           <a:p>
@@ -13304,7 +13208,7 @@
                 </a:solidFill>
                 <a:latin typeface="Pretendard"/>
               </a:rPr>
-              <a:t>GO FARTHER.</a:t>
+              <a:t>조금 더 멀리.</a:t>
             </a:r>
           </a:p>
         </p:txBody>
@@ -13318,7 +13222,7 @@
         <p:spPr>
           <a:xfrm>
             <a:off x="914400" y="7667625"/>
-            <a:ext cx="7439025" cy="1057275"/>
+            <a:ext cx="7600950" cy="447675"/>
           </a:xfrm>
           <a:prstGeom prst="rect">
             <a:avLst/>
@@ -13343,23 +13247,7 @@
                 </a:solidFill>
                 <a:latin typeface="Pretendard"/>
               </a:rPr>
-              <a:t>Progress built with PULSE shows</a:t>
-            </a:r>
-          </a:p>
-          <a:p>
-            <a:pPr algn="l">
-              <a:lnSpc>
-                <a:spcPts val="4725"/>
-              </a:lnSpc>
-            </a:pPr>
-            <a:r>
-              <a:rPr sz="3900" b="0" i="0">
-                <a:solidFill>
-                  <a:srgbClr val="C7BDD9"/>
-                </a:solidFill>
-                <a:latin typeface="Pretendard"/>
-              </a:rPr>
-              <a:t>up in the numbers.</a:t>
+              <a:t>결과 함께 만든 변화는 숫자로 남습니다.</a:t>
             </a:r>
           </a:p>
         </p:txBody>
@@ -13427,7 +13315,7 @@
         <p:spPr>
           <a:xfrm>
             <a:off x="1333500" y="9563100"/>
-            <a:ext cx="4105275" cy="323850"/>
+            <a:ext cx="2152650" cy="419100"/>
           </a:xfrm>
           <a:prstGeom prst="rect">
             <a:avLst/>
@@ -13448,7 +13336,7 @@
                 </a:solidFill>
                 <a:latin typeface="Pretendard"/>
               </a:rPr>
-              <a:t>VERIFIED REVIEW</a:t>
+              <a:t>확인된 후기</a:t>
             </a:r>
           </a:p>
         </p:txBody>
@@ -13532,7 +13420,7 @@
         <p:spPr>
           <a:xfrm>
             <a:off x="1333500" y="10858500"/>
-            <a:ext cx="4838700" cy="1181100"/>
+            <a:ext cx="4724400" cy="1285875"/>
           </a:xfrm>
           <a:prstGeom prst="rect">
             <a:avLst/>
@@ -13557,7 +13445,7 @@
                 </a:solidFill>
                 <a:latin typeface="Pretendard"/>
               </a:rPr>
-              <a:t>“I FINALLY RAN</a:t>
+              <a:t>“처음으로 5KM를</a:t>
             </a:r>
           </a:p>
           <a:p>
@@ -13573,7 +13461,7 @@
                 </a:solidFill>
                 <a:latin typeface="Pretendard"/>
               </a:rPr>
-              <a:t>MY FIRST 5K.”</a:t>
+              <a:t>끝까지 달렸어요.”</a:t>
             </a:r>
           </a:p>
         </p:txBody>
@@ -13587,7 +13475,7 @@
         <p:spPr>
           <a:xfrm>
             <a:off x="1333500" y="12744450"/>
-            <a:ext cx="5076825" cy="333375"/>
+            <a:ext cx="3705225" cy="419100"/>
           </a:xfrm>
           <a:prstGeom prst="rect">
             <a:avLst/>
@@ -13608,7 +13496,7 @@
                 </a:solidFill>
                 <a:latin typeface="Pretendard"/>
               </a:rPr>
-              <a:t>BETA TESTER  ·  WEEK 8</a:t>
+              <a:t>베타 테스터  ·  8주차</a:t>
             </a:r>
           </a:p>
         </p:txBody>
@@ -13622,7 +13510,7 @@
         <p:spPr>
           <a:xfrm>
             <a:off x="914400" y="14249400"/>
-            <a:ext cx="6353175" cy="819150"/>
+            <a:ext cx="6410325" cy="419100"/>
           </a:xfrm>
           <a:prstGeom prst="rect">
             <a:avLst/>
@@ -13647,23 +13535,7 @@
                 </a:solidFill>
                 <a:latin typeface="Pretendard"/>
               </a:rPr>
-              <a:t>YOUR NEXT PERSONAL BEST</a:t>
-            </a:r>
-          </a:p>
-          <a:p>
-            <a:pPr algn="l">
-              <a:lnSpc>
-                <a:spcPts val="3900"/>
-              </a:lnSpc>
-            </a:pPr>
-            <a:r>
-              <a:rPr sz="3600" b="0" i="0">
-                <a:solidFill>
-                  <a:srgbClr val="F8F4FF"/>
-                </a:solidFill>
-                <a:latin typeface="Pretendard"/>
-              </a:rPr>
-              <a:t>STARTS HERE.</a:t>
+              <a:t>다음 기록은 오늘 여기서 시작됩니다.</a:t>
             </a:r>
           </a:p>
         </p:txBody>
@@ -14293,13 +14165,13 @@
           <a:gradFill rotWithShape="1">
             <a:gsLst>
               <a:gs pos="0">
-                <a:srgbClr val="FE4F9A"/>
+                <a:srgbClr val="0A0712"/>
               </a:gs>
               <a:gs pos="100000">
-                <a:srgbClr val="9A6AFE"/>
+                <a:srgbClr val="0E0C1B"/>
               </a:gs>
             </a:gsLst>
-            <a:lin ang="6900000" scaled="0"/>
+            <a:lin ang="9900000" scaled="0"/>
           </a:gradFill>
           <a:ln>
             <a:noFill/>
@@ -14352,9 +14224,33 @@
           </a:prstGeom>
         </p:spPr>
       </p:pic>
-      <p:sp>
-        <p:nvSpPr>
-          <p:cNvPr id="4" name="Rounded Rectangle 3"/>
+      <p:pic>
+        <p:nvPicPr>
+          <p:cNvPr id="4" name="Picture 3" descr="image.png"/>
+          <p:cNvPicPr>
+            <a:picLocks noChangeAspect="1"/>
+          </p:cNvPicPr>
+          <p:nvPr/>
+        </p:nvPicPr>
+        <p:blipFill>
+          <a:blip r:embed="rId3"/>
+          <a:stretch>
+            <a:fillRect/>
+          </a:stretch>
+        </p:blipFill>
+        <p:spPr>
+          <a:xfrm>
+            <a:off x="0" y="0"/>
+            <a:ext cx="10287000" cy="18288000"/>
+          </a:xfrm>
+          <a:prstGeom prst="rect">
+            <a:avLst/>
+          </a:prstGeom>
+        </p:spPr>
+      </p:pic>
+      <p:sp>
+        <p:nvSpPr>
+          <p:cNvPr id="5" name="Rounded Rectangle 4"/>
           <p:cNvSpPr/>
           <p:nvPr/>
         </p:nvSpPr>
@@ -14369,8 +14265,8 @@
             </a:avLst>
           </a:prstGeom>
           <a:solidFill>
-            <a:srgbClr val="D640A9">
-              <a:alpha val="54901"/>
+            <a:srgbClr val="FF4F9A">
+              <a:alpha val="80000"/>
             </a:srgbClr>
           </a:solidFill>
           <a:ln>
@@ -14402,7 +14298,7 @@
       </p:sp>
       <p:sp>
         <p:nvSpPr>
-          <p:cNvPr id="5" name="Rounded Rectangle 4"/>
+          <p:cNvPr id="6" name="Rounded Rectangle 5"/>
           <p:cNvSpPr/>
           <p:nvPr/>
         </p:nvSpPr>
@@ -14417,8 +14313,8 @@
             </a:avLst>
           </a:prstGeom>
           <a:solidFill>
-            <a:srgbClr val="D640A9">
-              <a:alpha val="54901"/>
+            <a:srgbClr val="FF4F9A">
+              <a:alpha val="80000"/>
             </a:srgbClr>
           </a:solidFill>
           <a:ln>
@@ -14450,7 +14346,7 @@
       </p:sp>
       <p:sp>
         <p:nvSpPr>
-          <p:cNvPr id="6" name="Rounded Rectangle 5"/>
+          <p:cNvPr id="7" name="Rounded Rectangle 6"/>
           <p:cNvSpPr/>
           <p:nvPr/>
         </p:nvSpPr>
@@ -14465,8 +14361,8 @@
             </a:avLst>
           </a:prstGeom>
           <a:solidFill>
-            <a:srgbClr val="D640A9">
-              <a:alpha val="54901"/>
+            <a:srgbClr val="FF4F9A">
+              <a:alpha val="80000"/>
             </a:srgbClr>
           </a:solidFill>
           <a:ln>
@@ -14498,7 +14394,7 @@
       </p:sp>
       <p:sp>
         <p:nvSpPr>
-          <p:cNvPr id="7" name="Rounded Rectangle 6"/>
+          <p:cNvPr id="8" name="Rounded Rectangle 7"/>
           <p:cNvSpPr/>
           <p:nvPr/>
         </p:nvSpPr>
@@ -14513,8 +14409,8 @@
             </a:avLst>
           </a:prstGeom>
           <a:solidFill>
-            <a:srgbClr val="D640A9">
-              <a:alpha val="54901"/>
+            <a:srgbClr val="FF4F9A">
+              <a:alpha val="80000"/>
             </a:srgbClr>
           </a:solidFill>
           <a:ln>
@@ -14546,7 +14442,7 @@
       </p:sp>
       <p:sp>
         <p:nvSpPr>
-          <p:cNvPr id="8" name="Rounded Rectangle 7"/>
+          <p:cNvPr id="9" name="Rounded Rectangle 8"/>
           <p:cNvSpPr/>
           <p:nvPr/>
         </p:nvSpPr>
@@ -14561,8 +14457,8 @@
             </a:avLst>
           </a:prstGeom>
           <a:solidFill>
-            <a:srgbClr val="D640A9">
-              <a:alpha val="54901"/>
+            <a:srgbClr val="FF4F9A">
+              <a:alpha val="80000"/>
             </a:srgbClr>
           </a:solidFill>
           <a:ln>
@@ -14594,7 +14490,7 @@
       </p:sp>
       <p:sp>
         <p:nvSpPr>
-          <p:cNvPr id="9" name="Rounded Rectangle 8"/>
+          <p:cNvPr id="10" name="Rounded Rectangle 9"/>
           <p:cNvSpPr/>
           <p:nvPr/>
         </p:nvSpPr>
@@ -14609,8 +14505,8 @@
             </a:avLst>
           </a:prstGeom>
           <a:solidFill>
-            <a:srgbClr val="D640A9">
-              <a:alpha val="54901"/>
+            <a:srgbClr val="FF4F9A">
+              <a:alpha val="80000"/>
             </a:srgbClr>
           </a:solidFill>
           <a:ln>
@@ -14642,7 +14538,7 @@
       </p:sp>
       <p:sp>
         <p:nvSpPr>
-          <p:cNvPr id="10" name="Rounded Rectangle 9"/>
+          <p:cNvPr id="11" name="Rounded Rectangle 10"/>
           <p:cNvSpPr/>
           <p:nvPr/>
         </p:nvSpPr>
@@ -14657,8 +14553,8 @@
             </a:avLst>
           </a:prstGeom>
           <a:solidFill>
-            <a:srgbClr val="D640A9">
-              <a:alpha val="54901"/>
+            <a:srgbClr val="FF4F9A">
+              <a:alpha val="80000"/>
             </a:srgbClr>
           </a:solidFill>
           <a:ln>
@@ -14690,7 +14586,7 @@
       </p:sp>
       <p:sp>
         <p:nvSpPr>
-          <p:cNvPr id="11" name="Rounded Rectangle 10"/>
+          <p:cNvPr id="12" name="Rounded Rectangle 11"/>
           <p:cNvSpPr/>
           <p:nvPr/>
         </p:nvSpPr>
@@ -14736,14 +14632,14 @@
       </p:sp>
       <p:sp>
         <p:nvSpPr>
-          <p:cNvPr id="12" name="TextBox 11"/>
+          <p:cNvPr id="13" name="TextBox 12"/>
           <p:cNvSpPr txBox="1"/>
           <p:nvPr/>
         </p:nvSpPr>
         <p:spPr>
           <a:xfrm>
             <a:off x="914400" y="2762250"/>
-            <a:ext cx="1657350" cy="323850"/>
+            <a:ext cx="1685925" cy="323850"/>
           </a:xfrm>
           <a:prstGeom prst="rect">
             <a:avLst/>
@@ -14760,18 +14656,18 @@
             <a:r>
               <a:rPr sz="3600" b="0" i="0">
                 <a:solidFill>
-                  <a:srgbClr val="090711"/>
+                  <a:srgbClr val="F8F4FF"/>
                 </a:solidFill>
                 <a:latin typeface="Roboto"/>
               </a:rPr>
-              <a:t>PULSE</a:t>
-            </a:r>
-          </a:p>
-        </p:txBody>
-      </p:sp>
-      <p:sp>
-        <p:nvSpPr>
-          <p:cNvPr id="13" name="TextBox 12"/>
+              <a:t>GYEOL</a:t>
+            </a:r>
+          </a:p>
+        </p:txBody>
+      </p:sp>
+      <p:sp>
+        <p:nvSpPr>
+          <p:cNvPr id="14" name="TextBox 13"/>
           <p:cNvSpPr txBox="1"/>
           <p:nvPr/>
         </p:nvSpPr>
@@ -14795,7 +14691,7 @@
             <a:r>
               <a:rPr sz="3600" b="0" i="0">
                 <a:solidFill>
-                  <a:srgbClr val="090711"/>
+                  <a:srgbClr val="C7BDD9"/>
                 </a:solidFill>
                 <a:latin typeface="Pretendard"/>
               </a:rPr>
@@ -14806,14 +14702,14 @@
       </p:sp>
       <p:sp>
         <p:nvSpPr>
-          <p:cNvPr id="14" name="TextBox 13"/>
+          <p:cNvPr id="15" name="TextBox 14"/>
           <p:cNvSpPr txBox="1"/>
           <p:nvPr/>
         </p:nvSpPr>
         <p:spPr>
           <a:xfrm>
             <a:off x="914400" y="3905250"/>
-            <a:ext cx="5400675" cy="323850"/>
+            <a:ext cx="5476875" cy="323850"/>
           </a:xfrm>
           <a:prstGeom prst="rect">
             <a:avLst/>
@@ -14834,25 +14730,25 @@
             <a:r>
               <a:rPr sz="3600" b="0" i="0">
                 <a:solidFill>
-                  <a:srgbClr val="090711"/>
+                  <a:srgbClr val="FF4F9A"/>
                 </a:solidFill>
                 <a:latin typeface="Pretendard"/>
               </a:rPr>
-              <a:t>PULSE · START TODAY</a:t>
-            </a:r>
-          </a:p>
-        </p:txBody>
-      </p:sp>
-      <p:sp>
-        <p:nvSpPr>
-          <p:cNvPr id="15" name="TextBox 14"/>
+              <a:t>GYEOL · START TODAY</a:t>
+            </a:r>
+          </a:p>
+        </p:txBody>
+      </p:sp>
+      <p:sp>
+        <p:nvSpPr>
+          <p:cNvPr id="16" name="TextBox 15"/>
           <p:cNvSpPr txBox="1"/>
           <p:nvPr/>
         </p:nvSpPr>
         <p:spPr>
           <a:xfrm>
             <a:off x="914400" y="4762500"/>
-            <a:ext cx="4667250" cy="1990725"/>
+            <a:ext cx="7191375" cy="2209800"/>
           </a:xfrm>
           <a:prstGeom prst="rect">
             <a:avLst/>
@@ -14873,11 +14769,11 @@
             <a:r>
               <a:rPr sz="9300" b="0" i="0">
                 <a:solidFill>
-                  <a:srgbClr val="090711"/>
+                  <a:srgbClr val="FFFFFF"/>
                 </a:solidFill>
                 <a:latin typeface="Pretendard"/>
               </a:rPr>
-              <a:t>TIME TO</a:t>
+              <a:t>오늘, 다시 시작</a:t>
             </a:r>
           </a:p>
           <a:p>
@@ -14889,25 +14785,25 @@
             <a:r>
               <a:rPr sz="9300" b="0" i="0">
                 <a:solidFill>
-                  <a:srgbClr val="090711"/>
+                  <a:srgbClr val="FFFFFF"/>
                 </a:solidFill>
                 <a:latin typeface="Pretendard"/>
               </a:rPr>
-              <a:t>MOVE.</a:t>
-            </a:r>
-          </a:p>
-        </p:txBody>
-      </p:sp>
-      <p:sp>
-        <p:nvSpPr>
-          <p:cNvPr id="16" name="TextBox 15"/>
+              <a:t>나답게 움직이기</a:t>
+            </a:r>
+          </a:p>
+        </p:txBody>
+      </p:sp>
+      <p:sp>
+        <p:nvSpPr>
+          <p:cNvPr id="17" name="TextBox 16"/>
           <p:cNvSpPr txBox="1"/>
           <p:nvPr/>
         </p:nvSpPr>
         <p:spPr>
           <a:xfrm>
             <a:off x="914400" y="7667625"/>
-            <a:ext cx="6858000" cy="1047750"/>
+            <a:ext cx="6743700" cy="447675"/>
           </a:xfrm>
           <a:prstGeom prst="rect">
             <a:avLst/>
@@ -14928,34 +14824,18 @@
             <a:r>
               <a:rPr sz="3900" b="0" i="0">
                 <a:solidFill>
-                  <a:srgbClr val="32112F"/>
+                  <a:srgbClr val="C7BDD9"/>
                 </a:solidFill>
                 <a:latin typeface="Pretendard"/>
               </a:rPr>
-              <a:t>The fastest way to understand</a:t>
-            </a:r>
-          </a:p>
-          <a:p>
-            <a:pPr algn="l">
-              <a:lnSpc>
-                <a:spcPts val="4725"/>
-              </a:lnSpc>
-            </a:pPr>
-            <a:r>
-              <a:rPr sz="3900" b="0" i="0">
-                <a:solidFill>
-                  <a:srgbClr val="32112F"/>
-                </a:solidFill>
-                <a:latin typeface="Pretendard"/>
-              </a:rPr>
-              <a:t>your body.</a:t>
-            </a:r>
-          </a:p>
-        </p:txBody>
-      </p:sp>
-      <p:sp>
-        <p:nvSpPr>
-          <p:cNvPr id="17" name="Rounded Rectangle 16"/>
+              <a:t>내 몸을 이해하는 가장 선명한 방법.</a:t>
+            </a:r>
+          </a:p>
+        </p:txBody>
+      </p:sp>
+      <p:sp>
+        <p:nvSpPr>
+          <p:cNvPr id="18" name="Rounded Rectangle 17"/>
           <p:cNvSpPr/>
           <p:nvPr/>
         </p:nvSpPr>
@@ -14970,7 +14850,7 @@
             </a:avLst>
           </a:prstGeom>
           <a:solidFill>
-            <a:srgbClr val="090711"/>
+            <a:srgbClr val="FF4F9A"/>
           </a:solidFill>
           <a:ln>
             <a:noFill/>
@@ -15012,14 +14892,14 @@
       </p:sp>
       <p:sp>
         <p:nvSpPr>
-          <p:cNvPr id="18" name="TextBox 17"/>
+          <p:cNvPr id="19" name="TextBox 18"/>
           <p:cNvSpPr txBox="1"/>
           <p:nvPr/>
         </p:nvSpPr>
         <p:spPr>
           <a:xfrm>
-            <a:off x="3124200" y="10058400"/>
-            <a:ext cx="3190875" cy="390525"/>
+            <a:off x="3057525" y="10010775"/>
+            <a:ext cx="3324225" cy="485775"/>
           </a:xfrm>
           <a:prstGeom prst="rect">
             <a:avLst/>
@@ -15040,21 +14920,21 @@
                 </a:solidFill>
                 <a:latin typeface="Pretendard"/>
               </a:rPr>
-              <a:t>START FREE</a:t>
-            </a:r>
-          </a:p>
-        </p:txBody>
-      </p:sp>
-      <p:sp>
-        <p:nvSpPr>
-          <p:cNvPr id="19" name="TextBox 18"/>
+              <a:t>무료로 시작하기</a:t>
+            </a:r>
+          </a:p>
+        </p:txBody>
+      </p:sp>
+      <p:sp>
+        <p:nvSpPr>
+          <p:cNvPr id="20" name="TextBox 19"/>
           <p:cNvSpPr txBox="1"/>
           <p:nvPr/>
         </p:nvSpPr>
         <p:spPr>
           <a:xfrm>
             <a:off x="914400" y="11620500"/>
-            <a:ext cx="5943600" cy="819150"/>
+            <a:ext cx="5905500" cy="419100"/>
           </a:xfrm>
           <a:prstGeom prst="rect">
             <a:avLst/>
@@ -15075,62 +14955,46 @@
             <a:r>
               <a:rPr sz="3600" b="0" i="0">
                 <a:solidFill>
-                  <a:srgbClr val="090711"/>
+                  <a:srgbClr val="F8F4FF"/>
                 </a:solidFill>
                 <a:latin typeface="Pretendard"/>
               </a:rPr>
-              <a:t>4.9 RATING · 7 DAYS FREE ·</a:t>
-            </a:r>
-          </a:p>
-          <a:p>
-            <a:pPr algn="l">
-              <a:lnSpc>
-                <a:spcPts val="3900"/>
-              </a:lnSpc>
-            </a:pPr>
-            <a:r>
-              <a:rPr sz="3600" b="0" i="0">
+              <a:t>평점 4.9 · 7일 무료 · 언제든 해지</a:t>
+            </a:r>
+          </a:p>
+        </p:txBody>
+      </p:sp>
+      <p:sp>
+        <p:nvSpPr>
+          <p:cNvPr id="21" name="TextBox 20"/>
+          <p:cNvSpPr txBox="1"/>
+          <p:nvPr/>
+        </p:nvSpPr>
+        <p:spPr>
+          <a:xfrm>
+            <a:off x="914400" y="13811250"/>
+            <a:ext cx="3876675" cy="381000"/>
+          </a:xfrm>
+          <a:prstGeom prst="rect">
+            <a:avLst/>
+          </a:prstGeom>
+          <a:noFill/>
+        </p:spPr>
+        <p:txBody>
+          <a:bodyPr wrap="none" anchor="t" lIns="0" rIns="0" tIns="0" bIns="0">
+            <a:noAutofit/>
+          </a:bodyPr>
+          <a:lstStyle/>
+          <a:p>
+            <a:pPr algn="l"/>
+            <a:r>
+              <a:rPr sz="4050" b="0" i="0">
                 <a:solidFill>
-                  <a:srgbClr val="090711"/>
+                  <a:srgbClr val="F8F4FF"/>
                 </a:solidFill>
                 <a:latin typeface="Pretendard"/>
               </a:rPr>
-              <a:t>CANCEL ANYTIME</a:t>
-            </a:r>
-          </a:p>
-        </p:txBody>
-      </p:sp>
-      <p:sp>
-        <p:nvSpPr>
-          <p:cNvPr id="20" name="TextBox 19"/>
-          <p:cNvSpPr txBox="1"/>
-          <p:nvPr/>
-        </p:nvSpPr>
-        <p:spPr>
-          <a:xfrm>
-            <a:off x="914400" y="13811250"/>
-            <a:ext cx="3771900" cy="381000"/>
-          </a:xfrm>
-          <a:prstGeom prst="rect">
-            <a:avLst/>
-          </a:prstGeom>
-          <a:noFill/>
-        </p:spPr>
-        <p:txBody>
-          <a:bodyPr wrap="none" anchor="t" lIns="0" rIns="0" tIns="0" bIns="0">
-            <a:noAutofit/>
-          </a:bodyPr>
-          <a:lstStyle/>
-          <a:p>
-            <a:pPr algn="l"/>
-            <a:r>
-              <a:rPr sz="4050" b="0" i="0">
-                <a:solidFill>
-                  <a:srgbClr val="090711"/>
-                </a:solidFill>
-                <a:latin typeface="Pretendard"/>
-              </a:rPr>
-              <a:t>PULSE.APP  ↗</a:t>
+              <a:t>GYEOL.APP  ↗</a:t>
             </a:r>
           </a:p>
         </p:txBody>
@@ -15177,7 +15041,7 @@
                                           </p:stCondLst>
                                         </p:cTn>
                                         <p:tgtEl>
-                                          <p:spTgt spid="14"/>
+                                          <p:spTgt spid="15"/>
                                         </p:tgtEl>
                                         <p:attrNameLst>
                                           <p:attrName>style.visibility</p:attrName>
@@ -15191,7 +15055,7 @@
                                       <p:cBhvr>
                                         <p:cTn id="15" dur="281"/>
                                         <p:tgtEl>
-                                          <p:spTgt spid="14"/>
+                                          <p:spTgt spid="15"/>
                                         </p:tgtEl>
                                       </p:cBhvr>
                                     </p:animEffect>
@@ -15212,7 +15076,7 @@
                                           </p:stCondLst>
                                         </p:cTn>
                                         <p:tgtEl>
-                                          <p:spTgt spid="15"/>
+                                          <p:spTgt spid="16"/>
                                         </p:tgtEl>
                                         <p:attrNameLst>
                                           <p:attrName>style.visibility</p:attrName>
@@ -15226,7 +15090,7 @@
                                       <p:cBhvr>
                                         <p:cTn id="18" dur="422"/>
                                         <p:tgtEl>
-                                          <p:spTgt spid="15"/>
+                                          <p:spTgt spid="16"/>
                                         </p:tgtEl>
                                       </p:cBhvr>
                                     </p:animEffect>
@@ -15247,7 +15111,7 @@
                                           </p:stCondLst>
                                         </p:cTn>
                                         <p:tgtEl>
-                                          <p:spTgt spid="16"/>
+                                          <p:spTgt spid="17"/>
                                         </p:tgtEl>
                                         <p:attrNameLst>
                                           <p:attrName>style.visibility</p:attrName>
@@ -15261,7 +15125,7 @@
                                       <p:cBhvr>
                                         <p:cTn id="21" dur="281"/>
                                         <p:tgtEl>
-                                          <p:spTgt spid="16"/>
+                                          <p:spTgt spid="17"/>
                                         </p:tgtEl>
                                       </p:cBhvr>
                                     </p:animEffect>
@@ -15282,7 +15146,7 @@
                                           </p:stCondLst>
                                         </p:cTn>
                                         <p:tgtEl>
-                                          <p:spTgt spid="17"/>
+                                          <p:spTgt spid="18"/>
                                         </p:tgtEl>
                                         <p:attrNameLst>
                                           <p:attrName>style.visibility</p:attrName>
@@ -15296,7 +15160,7 @@
                                       <p:cBhvr>
                                         <p:cTn id="24" dur="375"/>
                                         <p:tgtEl>
-                                          <p:spTgt spid="17"/>
+                                          <p:spTgt spid="18"/>
                                         </p:tgtEl>
                                       </p:cBhvr>
                                     </p:animEffect>
@@ -15317,7 +15181,7 @@
                                           </p:stCondLst>
                                         </p:cTn>
                                         <p:tgtEl>
-                                          <p:spTgt spid="18"/>
+                                          <p:spTgt spid="19"/>
                                         </p:tgtEl>
                                         <p:attrNameLst>
                                           <p:attrName>style.visibility</p:attrName>
@@ -15331,7 +15195,7 @@
                                       <p:cBhvr>
                                         <p:cTn id="27" dur="281"/>
                                         <p:tgtEl>
-                                          <p:spTgt spid="18"/>
+                                          <p:spTgt spid="19"/>
                                         </p:tgtEl>
                                       </p:cBhvr>
                                     </p:animEffect>
@@ -15352,7 +15216,7 @@
                                           </p:stCondLst>
                                         </p:cTn>
                                         <p:tgtEl>
-                                          <p:spTgt spid="19"/>
+                                          <p:spTgt spid="20"/>
                                         </p:tgtEl>
                                         <p:attrNameLst>
                                           <p:attrName>style.visibility</p:attrName>
@@ -15366,7 +15230,7 @@
                                       <p:cBhvr>
                                         <p:cTn id="30" dur="281"/>
                                         <p:tgtEl>
-                                          <p:spTgt spid="19"/>
+                                          <p:spTgt spid="20"/>
                                         </p:tgtEl>
                                       </p:cBhvr>
                                     </p:animEffect>
@@ -15387,7 +15251,7 @@
                                           </p:stCondLst>
                                         </p:cTn>
                                         <p:tgtEl>
-                                          <p:spTgt spid="20"/>
+                                          <p:spTgt spid="21"/>
                                         </p:tgtEl>
                                         <p:attrNameLst>
                                           <p:attrName>style.visibility</p:attrName>
@@ -15401,7 +15265,7 @@
                                       <p:cBhvr>
                                         <p:cTn id="33" dur="281"/>
                                         <p:tgtEl>
-                                          <p:spTgt spid="20"/>
+                                          <p:spTgt spid="21"/>
                                         </p:tgtEl>
                                       </p:cBhvr>
                                     </p:animEffect>
@@ -15445,7 +15309,7 @@
                         </p:stCondLst>
                       </p:cTn>
                       <p:tgtEl>
-                        <p:spTgt spid="14"/>
+                        <p:spTgt spid="15"/>
                       </p:tgtEl>
                       <p:attrNameLst>
                         <p:attrName>style.visibility</p:attrName>
@@ -15463,7 +15327,7 @@
                         </p:stCondLst>
                       </p:cTn>
                       <p:tgtEl>
-                        <p:spTgt spid="15"/>
+                        <p:spTgt spid="16"/>
                       </p:tgtEl>
                       <p:attrNameLst>
                         <p:attrName>style.visibility</p:attrName>
@@ -15481,7 +15345,7 @@
                         </p:stCondLst>
                       </p:cTn>
                       <p:tgtEl>
-                        <p:spTgt spid="16"/>
+                        <p:spTgt spid="17"/>
                       </p:tgtEl>
                       <p:attrNameLst>
                         <p:attrName>style.visibility</p:attrName>
@@ -15499,7 +15363,7 @@
                         </p:stCondLst>
                       </p:cTn>
                       <p:tgtEl>
-                        <p:spTgt spid="17"/>
+                        <p:spTgt spid="18"/>
                       </p:tgtEl>
                       <p:attrNameLst>
                         <p:attrName>style.visibility</p:attrName>
@@ -15517,7 +15381,7 @@
                         </p:stCondLst>
                       </p:cTn>
                       <p:tgtEl>
-                        <p:spTgt spid="18"/>
+                        <p:spTgt spid="19"/>
                       </p:tgtEl>
                       <p:attrNameLst>
                         <p:attrName>style.visibility</p:attrName>
@@ -15535,7 +15399,7 @@
                         </p:stCondLst>
                       </p:cTn>
                       <p:tgtEl>
-                        <p:spTgt spid="19"/>
+                        <p:spTgt spid="20"/>
                       </p:tgtEl>
                       <p:attrNameLst>
                         <p:attrName>style.visibility</p:attrName>
@@ -15553,7 +15417,7 @@
                         </p:stCondLst>
                       </p:cTn>
                       <p:tgtEl>
-                        <p:spTgt spid="20"/>
+                        <p:spTgt spid="21"/>
                       </p:tgtEl>
                       <p:attrNameLst>
                         <p:attrName>style.visibility</p:attrName>

</xml_diff>

<commit_message>
feat: refine example compositions
</commit_message>
<xml_diff>
--- a/examples/product_hype_reel.pptx
+++ b/examples/product_hype_reel.pptx
@@ -3586,7 +3586,7 @@
         <p:spPr>
           <a:xfrm>
             <a:off x="914400" y="2762250"/>
-            <a:ext cx="1685925" cy="323850"/>
+            <a:ext cx="1657350" cy="323850"/>
           </a:xfrm>
           <a:prstGeom prst="rect">
             <a:avLst/>
@@ -3607,7 +3607,7 @@
                 </a:solidFill>
                 <a:latin typeface="Roboto"/>
               </a:rPr>
-              <a:t>GYEOL</a:t>
+              <a:t>PULSE</a:t>
             </a:r>
           </a:p>
         </p:txBody>
@@ -3695,7 +3695,7 @@
         <p:spPr>
           <a:xfrm>
             <a:off x="914400" y="4762500"/>
-            <a:ext cx="5572125" cy="1924050"/>
+            <a:ext cx="4867275" cy="2371725"/>
           </a:xfrm>
           <a:prstGeom prst="rect">
             <a:avLst/>
@@ -3710,33 +3710,49 @@
           <a:p>
             <a:pPr algn="l">
               <a:lnSpc>
-                <a:spcPts val="7725"/>
+                <a:spcPts val="6750"/>
               </a:lnSpc>
             </a:pPr>
             <a:r>
-              <a:rPr sz="8100" b="0" i="0">
+              <a:rPr sz="7125" b="0" i="0">
                 <a:solidFill>
                   <a:srgbClr val="FFFFFF"/>
                 </a:solidFill>
                 <a:latin typeface="Pretendard"/>
               </a:rPr>
-              <a:t>내 몸의 리듬을</a:t>
+              <a:t>TRAINING,</a:t>
             </a:r>
           </a:p>
           <a:p>
             <a:pPr algn="l">
               <a:lnSpc>
-                <a:spcPts val="7725"/>
+                <a:spcPts val="6750"/>
               </a:lnSpc>
             </a:pPr>
             <a:r>
-              <a:rPr sz="8100" b="0" i="0">
+              <a:rPr sz="7125" b="0" i="0">
                 <a:solidFill>
                   <a:srgbClr val="FFFFFF"/>
                 </a:solidFill>
                 <a:latin typeface="Pretendard"/>
               </a:rPr>
-              <a:t>다시 만나다.</a:t>
+              <a:t>MADE</a:t>
+            </a:r>
+          </a:p>
+          <a:p>
+            <a:pPr algn="l">
+              <a:lnSpc>
+                <a:spcPts val="6750"/>
+              </a:lnSpc>
+            </a:pPr>
+            <a:r>
+              <a:rPr sz="7125" b="0" i="0">
+                <a:solidFill>
+                  <a:srgbClr val="FFFFFF"/>
+                </a:solidFill>
+                <a:latin typeface="Pretendard"/>
+              </a:rPr>
+              <a:t>PERSONAL.</a:t>
             </a:r>
           </a:p>
         </p:txBody>
@@ -3750,7 +3766,7 @@
         <p:spPr>
           <a:xfrm>
             <a:off x="914400" y="7667625"/>
-            <a:ext cx="7486650" cy="1047750"/>
+            <a:ext cx="7248525" cy="1066800"/>
           </a:xfrm>
           <a:prstGeom prst="rect">
             <a:avLst/>
@@ -3775,7 +3791,7 @@
                 </a:solidFill>
                 <a:latin typeface="Pretendard"/>
               </a:rPr>
-              <a:t>심박부터 회복까지, 오늘의 몸을 한눈에</a:t>
+              <a:t>From heart rate to recovery, see</a:t>
             </a:r>
           </a:p>
           <a:p>
@@ -3791,7 +3807,7 @@
                 </a:solidFill>
                 <a:latin typeface="Pretendard"/>
               </a:rPr>
-              <a:t>읽습니다.</a:t>
+              <a:t>your rhythm at a glance.</a:t>
             </a:r>
           </a:p>
         </p:txBody>
@@ -3859,7 +3875,7 @@
         <p:spPr>
           <a:xfrm>
             <a:off x="1371600" y="9696450"/>
-            <a:ext cx="2686050" cy="419100"/>
+            <a:ext cx="4514850" cy="371475"/>
           </a:xfrm>
           <a:prstGeom prst="rect">
             <a:avLst/>
@@ -3880,7 +3896,7 @@
                 </a:solidFill>
                 <a:latin typeface="Pretendard"/>
               </a:rPr>
-              <a:t>●  실시간 심박</a:t>
+              <a:t>●  LIVE HEART RATE</a:t>
             </a:r>
           </a:p>
         </p:txBody>
@@ -3893,8 +3909,8 @@
         </p:nvSpPr>
         <p:spPr>
           <a:xfrm>
-            <a:off x="6886575" y="9696450"/>
-            <a:ext cx="1190625" cy="419100"/>
+            <a:off x="6438900" y="9696450"/>
+            <a:ext cx="1638300" cy="323850"/>
           </a:xfrm>
           <a:prstGeom prst="rect">
             <a:avLst/>
@@ -3915,7 +3931,7 @@
                 </a:solidFill>
                 <a:latin typeface="Pretendard"/>
               </a:rPr>
-              <a:t>구간 4</a:t>
+              <a:t>ZONE 4</a:t>
             </a:r>
           </a:p>
         </p:txBody>
@@ -4006,7 +4022,7 @@
         <p:spPr>
           <a:xfrm>
             <a:off x="1371600" y="12763500"/>
-            <a:ext cx="3429000" cy="409575"/>
+            <a:ext cx="6515100" cy="323850"/>
           </a:xfrm>
           <a:prstGeom prst="rect">
             <a:avLst/>
@@ -4027,7 +4043,7 @@
                 </a:solidFill>
                 <a:latin typeface="Pretendard"/>
               </a:rPr>
-              <a:t>심박수  ·  운동 강도</a:t>
+              <a:t>HEART RATE  ·  PERFORMANCE</a:t>
             </a:r>
           </a:p>
         </p:txBody>
@@ -4041,7 +4057,7 @@
         <p:spPr>
           <a:xfrm>
             <a:off x="914400" y="14249400"/>
-            <a:ext cx="5934075" cy="419100"/>
+            <a:ext cx="6877050" cy="323850"/>
           </a:xfrm>
           <a:prstGeom prst="rect">
             <a:avLst/>
@@ -4066,7 +4082,7 @@
                 </a:solidFill>
                 <a:latin typeface="Pretendard"/>
               </a:rPr>
-              <a:t>GYEOL · 나를 읽는 피트니스 OS</a:t>
+              <a:t>PULSE · PERSONAL FITNESS OS</a:t>
             </a:r>
           </a:p>
         </p:txBody>
@@ -5170,7 +5186,7 @@
         <p:spPr>
           <a:xfrm>
             <a:off x="914400" y="2762250"/>
-            <a:ext cx="1685925" cy="323850"/>
+            <a:ext cx="1657350" cy="323850"/>
           </a:xfrm>
           <a:prstGeom prst="rect">
             <a:avLst/>
@@ -5191,7 +5207,7 @@
                 </a:solidFill>
                 <a:latin typeface="Roboto"/>
               </a:rPr>
-              <a:t>GYEOL</a:t>
+              <a:t>PULSE</a:t>
             </a:r>
           </a:p>
         </p:txBody>
@@ -5240,7 +5256,7 @@
         <p:spPr>
           <a:xfrm>
             <a:off x="914400" y="3905250"/>
-            <a:ext cx="2562225" cy="428625"/>
+            <a:ext cx="3390900" cy="323850"/>
           </a:xfrm>
           <a:prstGeom prst="rect">
             <a:avLst/>
@@ -5265,7 +5281,7 @@
                 </a:solidFill>
                 <a:latin typeface="Pretendard"/>
               </a:rPr>
-              <a:t>꾸준함의 조건</a:t>
+              <a:t>THE PROBLEM</a:t>
             </a:r>
           </a:p>
         </p:txBody>
@@ -5279,7 +5295,7 @@
         <p:spPr>
           <a:xfrm>
             <a:off x="914400" y="4762500"/>
-            <a:ext cx="4772025" cy="1704975"/>
+            <a:ext cx="6286500" cy="2371725"/>
           </a:xfrm>
           <a:prstGeom prst="rect">
             <a:avLst/>
@@ -5294,33 +5310,49 @@
           <a:p>
             <a:pPr algn="l">
               <a:lnSpc>
-                <a:spcPts val="6825"/>
+                <a:spcPts val="6750"/>
               </a:lnSpc>
             </a:pPr>
             <a:r>
-              <a:rPr sz="7200" b="0" i="0">
+              <a:rPr sz="7125" b="0" i="0">
                 <a:solidFill>
                   <a:srgbClr val="FFFFFF"/>
                 </a:solidFill>
                 <a:latin typeface="Pretendard"/>
               </a:rPr>
-              <a:t>의지보다 먼저</a:t>
+              <a:t>CONSISTENCY</a:t>
             </a:r>
           </a:p>
           <a:p>
             <a:pPr algn="l">
               <a:lnSpc>
-                <a:spcPts val="6825"/>
+                <a:spcPts val="6750"/>
               </a:lnSpc>
             </a:pPr>
             <a:r>
-              <a:rPr sz="7200" b="0" i="0">
+              <a:rPr sz="7125" b="0" i="0">
                 <a:solidFill>
                   <a:srgbClr val="FFFFFF"/>
                 </a:solidFill>
                 <a:latin typeface="Pretendard"/>
               </a:rPr>
-              <a:t>필요한 것.</a:t>
+              <a:t>NEEDS A</a:t>
+            </a:r>
+          </a:p>
+          <a:p>
+            <a:pPr algn="l">
+              <a:lnSpc>
+                <a:spcPts val="6750"/>
+              </a:lnSpc>
+            </a:pPr>
+            <a:r>
+              <a:rPr sz="7125" b="0" i="0">
+                <a:solidFill>
+                  <a:srgbClr val="FFFFFF"/>
+                </a:solidFill>
+                <a:latin typeface="Pretendard"/>
+              </a:rPr>
+              <a:t>SYSTEM.</a:t>
             </a:r>
           </a:p>
         </p:txBody>
@@ -5334,7 +5366,7 @@
         <p:spPr>
           <a:xfrm>
             <a:off x="914400" y="7667625"/>
-            <a:ext cx="5514975" cy="1047750"/>
+            <a:ext cx="6286500" cy="981075"/>
           </a:xfrm>
           <a:prstGeom prst="rect">
             <a:avLst/>
@@ -5359,7 +5391,7 @@
                 </a:solidFill>
                 <a:latin typeface="Pretendard"/>
               </a:rPr>
-              <a:t>피드백이 늦으면 마음도 금세</a:t>
+              <a:t>When feedback arrives late,</a:t>
             </a:r>
           </a:p>
           <a:p>
@@ -5375,7 +5407,7 @@
                 </a:solidFill>
                 <a:latin typeface="Pretendard"/>
               </a:rPr>
-              <a:t>멀어집니다.</a:t>
+              <a:t>motivation follows.</a:t>
             </a:r>
           </a:p>
         </p:txBody>
@@ -5443,7 +5475,7 @@
         <p:spPr>
           <a:xfrm>
             <a:off x="1333500" y="9858375"/>
-            <a:ext cx="2552700" cy="419100"/>
+            <a:ext cx="4543425" cy="323850"/>
           </a:xfrm>
           <a:prstGeom prst="rect">
             <a:avLst/>
@@ -5464,7 +5496,7 @@
                 </a:solidFill>
                 <a:latin typeface="Pretendard"/>
               </a:rPr>
-              <a:t>평균 이탈 시점</a:t>
+              <a:t>AVERAGE DROP-OFF</a:t>
             </a:r>
           </a:p>
         </p:txBody>
@@ -5477,8 +5509,8 @@
         </p:nvSpPr>
         <p:spPr>
           <a:xfrm>
-            <a:off x="6219825" y="10258425"/>
-            <a:ext cx="1857375" cy="714375"/>
+            <a:off x="5105400" y="10258425"/>
+            <a:ext cx="2971800" cy="571500"/>
           </a:xfrm>
           <a:prstGeom prst="rect">
             <a:avLst/>
@@ -5499,7 +5531,7 @@
                 </a:solidFill>
                 <a:latin typeface="Pretendard"/>
               </a:rPr>
-              <a:t>3일째</a:t>
+              <a:t>DAY 03</a:t>
             </a:r>
           </a:p>
         </p:txBody>
@@ -5567,7 +5599,7 @@
         <p:spPr>
           <a:xfrm>
             <a:off x="1333500" y="11953875"/>
-            <a:ext cx="2447925" cy="419100"/>
+            <a:ext cx="3457575" cy="323850"/>
           </a:xfrm>
           <a:prstGeom prst="rect">
             <a:avLst/>
@@ -5588,7 +5620,7 @@
                 </a:solidFill>
                 <a:latin typeface="Pretendard"/>
               </a:rPr>
-              <a:t>실시간 피드백</a:t>
+              <a:t>LIVE FEEDBACK</a:t>
             </a:r>
           </a:p>
         </p:txBody>
@@ -5637,7 +5669,7 @@
         <p:spPr>
           <a:xfrm>
             <a:off x="914400" y="14249400"/>
-            <a:ext cx="6800850" cy="419100"/>
+            <a:ext cx="4962525" cy="819150"/>
           </a:xfrm>
           <a:prstGeom prst="rect">
             <a:avLst/>
@@ -5662,7 +5694,23 @@
                 </a:solidFill>
                 <a:latin typeface="Pretendard"/>
               </a:rPr>
-              <a:t>늦은 피드백은 움직일 마음을 놓칩니다.</a:t>
+              <a:t>LATE FEEDBACK KILLS</a:t>
+            </a:r>
+          </a:p>
+          <a:p>
+            <a:pPr algn="l">
+              <a:lnSpc>
+                <a:spcPts val="3900"/>
+              </a:lnSpc>
+            </a:pPr>
+            <a:r>
+              <a:rPr sz="3600" b="0" i="0">
+                <a:solidFill>
+                  <a:srgbClr val="F8F4FF"/>
+                </a:solidFill>
+                <a:latin typeface="Pretendard"/>
+              </a:rPr>
+              <a:t>MOMENTUM.</a:t>
             </a:r>
           </a:p>
         </p:txBody>
@@ -6766,7 +6814,7 @@
         <p:spPr>
           <a:xfrm>
             <a:off x="914400" y="2762250"/>
-            <a:ext cx="1685925" cy="323850"/>
+            <a:ext cx="1657350" cy="323850"/>
           </a:xfrm>
           <a:prstGeom prst="rect">
             <a:avLst/>
@@ -6787,7 +6835,7 @@
                 </a:solidFill>
                 <a:latin typeface="Roboto"/>
               </a:rPr>
-              <a:t>GYEOL</a:t>
+              <a:t>PULSE</a:t>
             </a:r>
           </a:p>
         </p:txBody>
@@ -6836,7 +6884,7 @@
         <p:spPr>
           <a:xfrm>
             <a:off x="914400" y="3905250"/>
-            <a:ext cx="3076575" cy="323850"/>
+            <a:ext cx="3000375" cy="323850"/>
           </a:xfrm>
           <a:prstGeom prst="rect">
             <a:avLst/>
@@ -6861,7 +6909,7 @@
                 </a:solidFill>
                 <a:latin typeface="Pretendard"/>
               </a:rPr>
-              <a:t>MEET GYEOL</a:t>
+              <a:t>MEET PULSE</a:t>
             </a:r>
           </a:p>
         </p:txBody>
@@ -6875,7 +6923,7 @@
         <p:spPr>
           <a:xfrm>
             <a:off x="914400" y="4762500"/>
-            <a:ext cx="6734175" cy="1924050"/>
+            <a:ext cx="7543800" cy="1571625"/>
           </a:xfrm>
           <a:prstGeom prst="rect">
             <a:avLst/>
@@ -6890,33 +6938,33 @@
           <a:p>
             <a:pPr algn="l">
               <a:lnSpc>
-                <a:spcPts val="7725"/>
+                <a:spcPts val="7050"/>
               </a:lnSpc>
             </a:pPr>
             <a:r>
-              <a:rPr sz="8100" b="0" i="0">
+              <a:rPr sz="7425" b="0" i="0">
                 <a:solidFill>
                   <a:srgbClr val="FFFFFF"/>
                 </a:solidFill>
                 <a:latin typeface="Pretendard"/>
               </a:rPr>
-              <a:t>흩어진 신호가</a:t>
+              <a:t>FIND YOUR</a:t>
             </a:r>
           </a:p>
           <a:p>
             <a:pPr algn="l">
               <a:lnSpc>
-                <a:spcPts val="7725"/>
+                <a:spcPts val="7050"/>
               </a:lnSpc>
             </a:pPr>
             <a:r>
-              <a:rPr sz="8100" b="0" i="0">
+              <a:rPr sz="7425" b="0" i="0">
                 <a:solidFill>
                   <a:srgbClr val="FFFFFF"/>
                 </a:solidFill>
                 <a:latin typeface="Pretendard"/>
               </a:rPr>
-              <a:t>하나의 리듬으로.</a:t>
+              <a:t>DAILY RHYTHM.</a:t>
             </a:r>
           </a:p>
         </p:txBody>
@@ -6930,7 +6978,7 @@
         <p:spPr>
           <a:xfrm>
             <a:off x="914400" y="7667625"/>
-            <a:ext cx="6496050" cy="1038225"/>
+            <a:ext cx="6953250" cy="1057275"/>
           </a:xfrm>
           <a:prstGeom prst="rect">
             <a:avLst/>
@@ -6955,7 +7003,7 @@
                 </a:solidFill>
                 <a:latin typeface="Pretendard"/>
               </a:rPr>
-              <a:t>복잡한 몸의 신호를 오늘의 점수로</a:t>
+              <a:t>Turn scattered signals into one</a:t>
             </a:r>
           </a:p>
           <a:p>
@@ -6971,7 +7019,7 @@
                 </a:solidFill>
                 <a:latin typeface="Pretendard"/>
               </a:rPr>
-              <a:t>바꿉니다.</a:t>
+              <a:t>clear daily score.</a:t>
             </a:r>
           </a:p>
         </p:txBody>
@@ -7039,7 +7087,7 @@
         <p:spPr>
           <a:xfrm>
             <a:off x="1371600" y="9696450"/>
-            <a:ext cx="1666875" cy="419100"/>
+            <a:ext cx="2428875" cy="323850"/>
           </a:xfrm>
           <a:prstGeom prst="rect">
             <a:avLst/>
@@ -7060,7 +7108,7 @@
                 </a:solidFill>
                 <a:latin typeface="Pretendard"/>
               </a:rPr>
-              <a:t>회복 점수</a:t>
+              <a:t>RECOVERY</a:t>
             </a:r>
           </a:p>
         </p:txBody>
@@ -7151,7 +7199,7 @@
         <p:spPr>
           <a:xfrm>
             <a:off x="1371600" y="12192000"/>
-            <a:ext cx="3819525" cy="857250"/>
+            <a:ext cx="5019675" cy="790575"/>
           </a:xfrm>
           <a:prstGeom prst="rect">
             <a:avLst/>
@@ -7176,7 +7224,7 @@
                 </a:solidFill>
                 <a:latin typeface="Pretendard"/>
               </a:rPr>
-              <a:t>수면 92 · 에너지 81</a:t>
+              <a:t>SLEEP 92 · ENERGY 81</a:t>
             </a:r>
           </a:p>
           <a:p>
@@ -7192,7 +7240,7 @@
                 </a:solidFill>
                 <a:latin typeface="Pretendard"/>
               </a:rPr>
-              <a:t>스트레스 24</a:t>
+              <a:t>STRESS 24</a:t>
             </a:r>
           </a:p>
         </p:txBody>
@@ -7206,7 +7254,7 @@
         <p:spPr>
           <a:xfrm>
             <a:off x="914400" y="14249400"/>
-            <a:ext cx="5524500" cy="419100"/>
+            <a:ext cx="5848350" cy="819150"/>
           </a:xfrm>
           <a:prstGeom prst="rect">
             <a:avLst/>
@@ -7231,7 +7279,23 @@
                 </a:solidFill>
                 <a:latin typeface="Pretendard"/>
               </a:rPr>
-              <a:t>오늘의 몸을 한눈에 읽어보세요.</a:t>
+              <a:t>READ TODAY'S BODY AT A</a:t>
+            </a:r>
+          </a:p>
+          <a:p>
+            <a:pPr algn="l">
+              <a:lnSpc>
+                <a:spcPts val="3900"/>
+              </a:lnSpc>
+            </a:pPr>
+            <a:r>
+              <a:rPr sz="3600" b="0" i="0">
+                <a:solidFill>
+                  <a:srgbClr val="F8F4FF"/>
+                </a:solidFill>
+                <a:latin typeface="Pretendard"/>
+              </a:rPr>
+              <a:t>GLANCE.</a:t>
             </a:r>
           </a:p>
         </p:txBody>
@@ -8282,7 +8346,7 @@
         <p:spPr>
           <a:xfrm>
             <a:off x="914400" y="2762250"/>
-            <a:ext cx="1685925" cy="323850"/>
+            <a:ext cx="1657350" cy="323850"/>
           </a:xfrm>
           <a:prstGeom prst="rect">
             <a:avLst/>
@@ -8303,7 +8367,7 @@
                 </a:solidFill>
                 <a:latin typeface="Roboto"/>
               </a:rPr>
-              <a:t>GYEOL</a:t>
+              <a:t>PULSE</a:t>
             </a:r>
           </a:p>
         </p:txBody>
@@ -8391,7 +8455,7 @@
         <p:spPr>
           <a:xfrm>
             <a:off x="914400" y="4762500"/>
-            <a:ext cx="5524500" cy="1647825"/>
+            <a:ext cx="5295900" cy="1485900"/>
           </a:xfrm>
           <a:prstGeom prst="rect">
             <a:avLst/>
@@ -8416,7 +8480,7 @@
                 </a:solidFill>
                 <a:latin typeface="Pretendard"/>
               </a:rPr>
-              <a:t>움직이는 순간을</a:t>
+              <a:t>NEVER MISS</a:t>
             </a:r>
           </a:p>
           <a:p>
@@ -8432,7 +8496,7 @@
                 </a:solidFill>
                 <a:latin typeface="Pretendard"/>
               </a:rPr>
-              <a:t>놓치지 않게.</a:t>
+              <a:t>A BEAT.</a:t>
             </a:r>
           </a:p>
         </p:txBody>
@@ -8446,7 +8510,7 @@
         <p:spPr>
           <a:xfrm>
             <a:off x="914400" y="7667625"/>
-            <a:ext cx="6924675" cy="1047750"/>
+            <a:ext cx="6115050" cy="1057275"/>
           </a:xfrm>
           <a:prstGeom prst="rect">
             <a:avLst/>
@@ -8471,7 +8535,7 @@
                 </a:solidFill>
                 <a:latin typeface="Pretendard"/>
               </a:rPr>
-              <a:t>심박 구간과 운동 강도를 실시간으로</a:t>
+              <a:t>Track heart-rate zones and</a:t>
             </a:r>
           </a:p>
           <a:p>
@@ -8487,7 +8551,7 @@
                 </a:solidFill>
                 <a:latin typeface="Pretendard"/>
               </a:rPr>
-              <a:t>읽습니다.</a:t>
+              <a:t>workout intensity live.</a:t>
             </a:r>
           </a:p>
         </p:txBody>
@@ -8555,7 +8619,7 @@
         <p:spPr>
           <a:xfrm>
             <a:off x="1371600" y="9696450"/>
-            <a:ext cx="2066925" cy="419100"/>
+            <a:ext cx="3895725" cy="323850"/>
           </a:xfrm>
           <a:prstGeom prst="rect">
             <a:avLst/>
@@ -8576,7 +8640,7 @@
                 </a:solidFill>
                 <a:latin typeface="Pretendard"/>
               </a:rPr>
-              <a:t>실시간 심박</a:t>
+              <a:t>LIVE HEART RATE</a:t>
             </a:r>
           </a:p>
         </p:txBody>
@@ -8702,7 +8766,7 @@
         <p:spPr>
           <a:xfrm>
             <a:off x="1371600" y="12192000"/>
-            <a:ext cx="4724400" cy="419100"/>
+            <a:ext cx="6667500" cy="333375"/>
           </a:xfrm>
           <a:prstGeom prst="rect">
             <a:avLst/>
@@ -8727,7 +8791,7 @@
                 </a:solidFill>
                 <a:latin typeface="Pretendard"/>
               </a:rPr>
-              <a:t>워밍업 · 지방 연소 · 유산소</a:t>
+              <a:t>WARM-UP · FAT BURN · CARDIO</a:t>
             </a:r>
           </a:p>
         </p:txBody>
@@ -8741,7 +8805,7 @@
         <p:spPr>
           <a:xfrm>
             <a:off x="914400" y="14249400"/>
-            <a:ext cx="7315200" cy="914400"/>
+            <a:ext cx="7315200" cy="323850"/>
           </a:xfrm>
           <a:prstGeom prst="rect">
             <a:avLst/>
@@ -8767,22 +8831,6 @@
                 <a:latin typeface="Pretendard"/>
               </a:rPr>
               <a:t>APPLE WATCH · GALAXY WATCH</a:t>
-            </a:r>
-          </a:p>
-          <a:p>
-            <a:pPr algn="l">
-              <a:lnSpc>
-                <a:spcPts val="3900"/>
-              </a:lnSpc>
-            </a:pPr>
-            <a:r>
-              <a:rPr sz="3600" b="0" i="0">
-                <a:solidFill>
-                  <a:srgbClr val="F8F4FF"/>
-                </a:solidFill>
-                <a:latin typeface="Pretendard"/>
-              </a:rPr>
-              <a:t>연동</a:t>
             </a:r>
           </a:p>
         </p:txBody>
@@ -9886,7 +9934,7 @@
         <p:spPr>
           <a:xfrm>
             <a:off x="914400" y="2762250"/>
-            <a:ext cx="1685925" cy="323850"/>
+            <a:ext cx="1657350" cy="323850"/>
           </a:xfrm>
           <a:prstGeom prst="rect">
             <a:avLst/>
@@ -9907,7 +9955,7 @@
                 </a:solidFill>
                 <a:latin typeface="Roboto"/>
               </a:rPr>
-              <a:t>GYEOL</a:t>
+              <a:t>PULSE</a:t>
             </a:r>
           </a:p>
         </p:txBody>
@@ -9995,7 +10043,7 @@
         <p:spPr>
           <a:xfrm>
             <a:off x="914400" y="4762500"/>
-            <a:ext cx="5153025" cy="1685925"/>
+            <a:ext cx="7038975" cy="1514475"/>
           </a:xfrm>
           <a:prstGeom prst="rect">
             <a:avLst/>
@@ -10020,7 +10068,7 @@
                 </a:solidFill>
                 <a:latin typeface="Pretendard"/>
               </a:rPr>
-              <a:t>오늘의 속도는</a:t>
+              <a:t>AI SETS</a:t>
             </a:r>
           </a:p>
           <a:p>
@@ -10036,7 +10084,7 @@
                 </a:solidFill>
                 <a:latin typeface="Pretendard"/>
               </a:rPr>
-              <a:t>몸이 정하니까.</a:t>
+              <a:t>TODAY'S PACE.</a:t>
             </a:r>
           </a:p>
         </p:txBody>
@@ -10050,7 +10098,7 @@
         <p:spPr>
           <a:xfrm>
             <a:off x="914400" y="7667625"/>
-            <a:ext cx="6067425" cy="1047750"/>
+            <a:ext cx="6962775" cy="962025"/>
           </a:xfrm>
           <a:prstGeom prst="rect">
             <a:avLst/>
@@ -10075,7 +10123,7 @@
                 </a:solidFill>
                 <a:latin typeface="Pretendard"/>
               </a:rPr>
-              <a:t>회복 상태에 맞춰 시간과 강도를</a:t>
+              <a:t>Adapt duration and intensity to</a:t>
             </a:r>
           </a:p>
           <a:p>
@@ -10091,7 +10139,7 @@
                 </a:solidFill>
                 <a:latin typeface="Pretendard"/>
               </a:rPr>
-              <a:t>조정합니다.</a:t>
+              <a:t>your recovery.</a:t>
             </a:r>
           </a:p>
         </p:txBody>
@@ -10159,7 +10207,7 @@
         <p:spPr>
           <a:xfrm>
             <a:off x="1371600" y="9696450"/>
-            <a:ext cx="2447925" cy="419100"/>
+            <a:ext cx="3333750" cy="323850"/>
           </a:xfrm>
           <a:prstGeom prst="rect">
             <a:avLst/>
@@ -10180,7 +10228,7 @@
                 </a:solidFill>
                 <a:latin typeface="Pretendard"/>
               </a:rPr>
-              <a:t>오늘의 운동량</a:t>
+              <a:t>TODAY'S LOAD</a:t>
             </a:r>
           </a:p>
         </p:txBody>
@@ -10345,7 +10393,7 @@
         <p:spPr>
           <a:xfrm>
             <a:off x="914400" y="14249400"/>
-            <a:ext cx="5629275" cy="419100"/>
+            <a:ext cx="7477125" cy="819150"/>
           </a:xfrm>
           <a:prstGeom prst="rect">
             <a:avLst/>
@@ -10370,7 +10418,23 @@
                 </a:solidFill>
                 <a:latin typeface="Pretendard"/>
               </a:rPr>
-              <a:t>매일 달라지는 나에게 맞춘 코칭.</a:t>
+              <a:t>A COACHING PLAN THAT ADAPTS</a:t>
+            </a:r>
+          </a:p>
+          <a:p>
+            <a:pPr algn="l">
+              <a:lnSpc>
+                <a:spcPts val="3900"/>
+              </a:lnSpc>
+            </a:pPr>
+            <a:r>
+              <a:rPr sz="3600" b="0" i="0">
+                <a:solidFill>
+                  <a:srgbClr val="F8F4FF"/>
+                </a:solidFill>
+                <a:latin typeface="Pretendard"/>
+              </a:rPr>
+              <a:t>EVERY DAY.</a:t>
             </a:r>
           </a:p>
         </p:txBody>
@@ -11474,7 +11538,7 @@
         <p:spPr>
           <a:xfrm>
             <a:off x="914400" y="2762250"/>
-            <a:ext cx="1685925" cy="323850"/>
+            <a:ext cx="1657350" cy="323850"/>
           </a:xfrm>
           <a:prstGeom prst="rect">
             <a:avLst/>
@@ -11495,7 +11559,7 @@
                 </a:solidFill>
                 <a:latin typeface="Roboto"/>
               </a:rPr>
-              <a:t>GYEOL</a:t>
+              <a:t>PULSE</a:t>
             </a:r>
           </a:p>
         </p:txBody>
@@ -11583,7 +11647,7 @@
         <p:spPr>
           <a:xfrm>
             <a:off x="914400" y="4762500"/>
-            <a:ext cx="6543675" cy="1704975"/>
+            <a:ext cx="7600950" cy="2286000"/>
           </a:xfrm>
           <a:prstGeom prst="rect">
             <a:avLst/>
@@ -11598,33 +11662,49 @@
           <a:p>
             <a:pPr algn="l">
               <a:lnSpc>
-                <a:spcPts val="6825"/>
+                <a:spcPts val="6525"/>
               </a:lnSpc>
             </a:pPr>
             <a:r>
-              <a:rPr sz="7200" b="0" i="0">
+              <a:rPr sz="6825" b="0" i="0">
                 <a:solidFill>
                   <a:srgbClr val="FFFFFF"/>
                 </a:solidFill>
                 <a:latin typeface="Pretendard"/>
               </a:rPr>
-              <a:t>작은 사흘이</a:t>
+              <a:t>TURN THREE DAYS</a:t>
             </a:r>
           </a:p>
           <a:p>
             <a:pPr algn="l">
               <a:lnSpc>
-                <a:spcPts val="6825"/>
+                <a:spcPts val="6525"/>
               </a:lnSpc>
             </a:pPr>
             <a:r>
-              <a:rPr sz="7200" b="0" i="0">
+              <a:rPr sz="6825" b="0" i="0">
                 <a:solidFill>
                   <a:srgbClr val="FFFFFF"/>
                 </a:solidFill>
                 <a:latin typeface="Pretendard"/>
               </a:rPr>
-              <a:t>스물하루가 되도록.</a:t>
+              <a:t>INTO</a:t>
+            </a:r>
+          </a:p>
+          <a:p>
+            <a:pPr algn="l">
+              <a:lnSpc>
+                <a:spcPts val="6525"/>
+              </a:lnSpc>
+            </a:pPr>
+            <a:r>
+              <a:rPr sz="6825" b="0" i="0">
+                <a:solidFill>
+                  <a:srgbClr val="FFFFFF"/>
+                </a:solidFill>
+                <a:latin typeface="Pretendard"/>
+              </a:rPr>
+              <a:t>TWENTY-ONE.</a:t>
             </a:r>
           </a:p>
         </p:txBody>
@@ -11638,7 +11718,7 @@
         <p:spPr>
           <a:xfrm>
             <a:off x="914400" y="7667625"/>
-            <a:ext cx="5943600" cy="1047750"/>
+            <a:ext cx="7029450" cy="962025"/>
           </a:xfrm>
           <a:prstGeom prst="rect">
             <a:avLst/>
@@ -11663,7 +11743,7 @@
                 </a:solidFill>
                 <a:latin typeface="Pretendard"/>
               </a:rPr>
-              <a:t>작은 성공을 오래가는 습관으로</a:t>
+              <a:t>Link small wins into a habit that</a:t>
             </a:r>
           </a:p>
           <a:p>
@@ -11679,7 +11759,7 @@
                 </a:solidFill>
                 <a:latin typeface="Pretendard"/>
               </a:rPr>
-              <a:t>연결합니다.</a:t>
+              <a:t>lasts.</a:t>
             </a:r>
           </a:p>
         </p:txBody>
@@ -11747,7 +11827,7 @@
         <p:spPr>
           <a:xfrm>
             <a:off x="1371600" y="9696450"/>
-            <a:ext cx="1171575" cy="409575"/>
+            <a:ext cx="3248025" cy="323850"/>
           </a:xfrm>
           <a:prstGeom prst="rect">
             <a:avLst/>
@@ -11768,7 +11848,7 @@
                 </a:solidFill>
                 <a:latin typeface="Pretendard"/>
               </a:rPr>
-              <a:t>꾸준함</a:t>
+              <a:t>CONSISTENCY</a:t>
             </a:r>
           </a:p>
         </p:txBody>
@@ -11781,8 +11861,8 @@
         </p:nvSpPr>
         <p:spPr>
           <a:xfrm>
-            <a:off x="6410325" y="9696450"/>
-            <a:ext cx="1666875" cy="419100"/>
+            <a:off x="6905625" y="9696450"/>
+            <a:ext cx="1171575" cy="323850"/>
           </a:xfrm>
           <a:prstGeom prst="rect">
             <a:avLst/>
@@ -11803,7 +11883,7 @@
                 </a:solidFill>
                 <a:latin typeface="Pretendard"/>
               </a:rPr>
-              <a:t>최고 기록</a:t>
+              <a:t>BEST</a:t>
             </a:r>
           </a:p>
         </p:txBody>
@@ -11859,7 +11939,7 @@
         <p:spPr>
           <a:xfrm>
             <a:off x="4095750" y="11715750"/>
-            <a:ext cx="1400175" cy="447675"/>
+            <a:ext cx="3162300" cy="371475"/>
           </a:xfrm>
           <a:prstGeom prst="rect">
             <a:avLst/>
@@ -11880,7 +11960,7 @@
                 </a:solidFill>
                 <a:latin typeface="Pretendard"/>
               </a:rPr>
-              <a:t>일 연속</a:t>
+              <a:t>DAY STREAK</a:t>
             </a:r>
           </a:p>
         </p:txBody>
@@ -11929,7 +12009,7 @@
         <p:spPr>
           <a:xfrm>
             <a:off x="914400" y="14249400"/>
-            <a:ext cx="6305550" cy="419100"/>
+            <a:ext cx="7191375" cy="819150"/>
           </a:xfrm>
           <a:prstGeom prst="rect">
             <a:avLst/>
@@ -11954,7 +12034,23 @@
                 </a:solidFill>
                 <a:latin typeface="Pretendard"/>
               </a:rPr>
-              <a:t>꾸준함이 보이면 습관은 계속됩니다.</a:t>
+              <a:t>WHEN CONSISTENCY IS VISIBLE,</a:t>
+            </a:r>
+          </a:p>
+          <a:p>
+            <a:pPr algn="l">
+              <a:lnSpc>
+                <a:spcPts val="3900"/>
+              </a:lnSpc>
+            </a:pPr>
+            <a:r>
+              <a:rPr sz="3600" b="0" i="0">
+                <a:solidFill>
+                  <a:srgbClr val="F8F4FF"/>
+                </a:solidFill>
+                <a:latin typeface="Pretendard"/>
+              </a:rPr>
+              <a:t>HABITS KEEP GOING.</a:t>
             </a:r>
           </a:p>
         </p:txBody>
@@ -13058,7 +13154,7 @@
         <p:spPr>
           <a:xfrm>
             <a:off x="914400" y="2762250"/>
-            <a:ext cx="1685925" cy="323850"/>
+            <a:ext cx="1657350" cy="323850"/>
           </a:xfrm>
           <a:prstGeom prst="rect">
             <a:avLst/>
@@ -13079,7 +13175,7 @@
                 </a:solidFill>
                 <a:latin typeface="Roboto"/>
               </a:rPr>
-              <a:t>GYEOL</a:t>
+              <a:t>PULSE</a:t>
             </a:r>
           </a:p>
         </p:txBody>
@@ -13128,7 +13224,7 @@
         <p:spPr>
           <a:xfrm>
             <a:off x="914400" y="3905250"/>
-            <a:ext cx="4267200" cy="466725"/>
+            <a:ext cx="4848225" cy="419100"/>
           </a:xfrm>
           <a:prstGeom prst="rect">
             <a:avLst/>
@@ -13153,7 +13249,7 @@
                 </a:solidFill>
                 <a:latin typeface="Pretendard"/>
               </a:rPr>
-              <a:t>4.9 · 2,841개의 기록</a:t>
+              <a:t>4.9 · 2,841 REVIEWS</a:t>
             </a:r>
           </a:p>
         </p:txBody>
@@ -13167,7 +13263,7 @@
         <p:spPr>
           <a:xfrm>
             <a:off x="914400" y="4762500"/>
-            <a:ext cx="4610100" cy="1771650"/>
+            <a:ext cx="6067425" cy="1600200"/>
           </a:xfrm>
           <a:prstGeom prst="rect">
             <a:avLst/>
@@ -13192,7 +13288,7 @@
                 </a:solidFill>
                 <a:latin typeface="Pretendard"/>
               </a:rPr>
-              <a:t>조금 더 오래,</a:t>
+              <a:t>GO LONGER.</a:t>
             </a:r>
           </a:p>
           <a:p>
@@ -13208,7 +13304,7 @@
                 </a:solidFill>
                 <a:latin typeface="Pretendard"/>
               </a:rPr>
-              <a:t>조금 더 멀리.</a:t>
+              <a:t>GO FARTHER.</a:t>
             </a:r>
           </a:p>
         </p:txBody>
@@ -13222,7 +13318,7 @@
         <p:spPr>
           <a:xfrm>
             <a:off x="914400" y="7667625"/>
-            <a:ext cx="7600950" cy="447675"/>
+            <a:ext cx="7439025" cy="1057275"/>
           </a:xfrm>
           <a:prstGeom prst="rect">
             <a:avLst/>
@@ -13247,7 +13343,23 @@
                 </a:solidFill>
                 <a:latin typeface="Pretendard"/>
               </a:rPr>
-              <a:t>결과 함께 만든 변화는 숫자로 남습니다.</a:t>
+              <a:t>Progress built with PULSE shows</a:t>
+            </a:r>
+          </a:p>
+          <a:p>
+            <a:pPr algn="l">
+              <a:lnSpc>
+                <a:spcPts val="4725"/>
+              </a:lnSpc>
+            </a:pPr>
+            <a:r>
+              <a:rPr sz="3900" b="0" i="0">
+                <a:solidFill>
+                  <a:srgbClr val="C7BDD9"/>
+                </a:solidFill>
+                <a:latin typeface="Pretendard"/>
+              </a:rPr>
+              <a:t>up in the numbers.</a:t>
             </a:r>
           </a:p>
         </p:txBody>
@@ -13315,7 +13427,7 @@
         <p:spPr>
           <a:xfrm>
             <a:off x="1333500" y="9563100"/>
-            <a:ext cx="2152650" cy="419100"/>
+            <a:ext cx="4105275" cy="323850"/>
           </a:xfrm>
           <a:prstGeom prst="rect">
             <a:avLst/>
@@ -13336,7 +13448,7 @@
                 </a:solidFill>
                 <a:latin typeface="Pretendard"/>
               </a:rPr>
-              <a:t>확인된 후기</a:t>
+              <a:t>VERIFIED REVIEW</a:t>
             </a:r>
           </a:p>
         </p:txBody>
@@ -13420,7 +13532,7 @@
         <p:spPr>
           <a:xfrm>
             <a:off x="1333500" y="10858500"/>
-            <a:ext cx="4724400" cy="1285875"/>
+            <a:ext cx="4838700" cy="1181100"/>
           </a:xfrm>
           <a:prstGeom prst="rect">
             <a:avLst/>
@@ -13445,7 +13557,7 @@
                 </a:solidFill>
                 <a:latin typeface="Pretendard"/>
               </a:rPr>
-              <a:t>“처음으로 5KM를</a:t>
+              <a:t>“I FINALLY RAN</a:t>
             </a:r>
           </a:p>
           <a:p>
@@ -13461,7 +13573,7 @@
                 </a:solidFill>
                 <a:latin typeface="Pretendard"/>
               </a:rPr>
-              <a:t>끝까지 달렸어요.”</a:t>
+              <a:t>MY FIRST 5K.”</a:t>
             </a:r>
           </a:p>
         </p:txBody>
@@ -13475,7 +13587,7 @@
         <p:spPr>
           <a:xfrm>
             <a:off x="1333500" y="12744450"/>
-            <a:ext cx="3705225" cy="419100"/>
+            <a:ext cx="5076825" cy="333375"/>
           </a:xfrm>
           <a:prstGeom prst="rect">
             <a:avLst/>
@@ -13496,7 +13608,7 @@
                 </a:solidFill>
                 <a:latin typeface="Pretendard"/>
               </a:rPr>
-              <a:t>베타 테스터  ·  8주차</a:t>
+              <a:t>BETA TESTER  ·  WEEK 8</a:t>
             </a:r>
           </a:p>
         </p:txBody>
@@ -13510,7 +13622,7 @@
         <p:spPr>
           <a:xfrm>
             <a:off x="914400" y="14249400"/>
-            <a:ext cx="6410325" cy="419100"/>
+            <a:ext cx="6353175" cy="819150"/>
           </a:xfrm>
           <a:prstGeom prst="rect">
             <a:avLst/>
@@ -13535,7 +13647,23 @@
                 </a:solidFill>
                 <a:latin typeface="Pretendard"/>
               </a:rPr>
-              <a:t>다음 기록은 오늘 여기서 시작됩니다.</a:t>
+              <a:t>YOUR NEXT PERSONAL BEST</a:t>
+            </a:r>
+          </a:p>
+          <a:p>
+            <a:pPr algn="l">
+              <a:lnSpc>
+                <a:spcPts val="3900"/>
+              </a:lnSpc>
+            </a:pPr>
+            <a:r>
+              <a:rPr sz="3600" b="0" i="0">
+                <a:solidFill>
+                  <a:srgbClr val="F8F4FF"/>
+                </a:solidFill>
+                <a:latin typeface="Pretendard"/>
+              </a:rPr>
+              <a:t>STARTS HERE.</a:t>
             </a:r>
           </a:p>
         </p:txBody>
@@ -14165,13 +14293,13 @@
           <a:gradFill rotWithShape="1">
             <a:gsLst>
               <a:gs pos="0">
-                <a:srgbClr val="0A0712"/>
+                <a:srgbClr val="FE4F9A"/>
               </a:gs>
               <a:gs pos="100000">
-                <a:srgbClr val="0E0C1B"/>
+                <a:srgbClr val="9A6AFE"/>
               </a:gs>
             </a:gsLst>
-            <a:lin ang="9900000" scaled="0"/>
+            <a:lin ang="6900000" scaled="0"/>
           </a:gradFill>
           <a:ln>
             <a:noFill/>
@@ -14224,33 +14352,9 @@
           </a:prstGeom>
         </p:spPr>
       </p:pic>
-      <p:pic>
-        <p:nvPicPr>
-          <p:cNvPr id="4" name="Picture 3" descr="image.png"/>
-          <p:cNvPicPr>
-            <a:picLocks noChangeAspect="1"/>
-          </p:cNvPicPr>
-          <p:nvPr/>
-        </p:nvPicPr>
-        <p:blipFill>
-          <a:blip r:embed="rId3"/>
-          <a:stretch>
-            <a:fillRect/>
-          </a:stretch>
-        </p:blipFill>
-        <p:spPr>
-          <a:xfrm>
-            <a:off x="0" y="0"/>
-            <a:ext cx="10287000" cy="18288000"/>
-          </a:xfrm>
-          <a:prstGeom prst="rect">
-            <a:avLst/>
-          </a:prstGeom>
-        </p:spPr>
-      </p:pic>
-      <p:sp>
-        <p:nvSpPr>
-          <p:cNvPr id="5" name="Rounded Rectangle 4"/>
+      <p:sp>
+        <p:nvSpPr>
+          <p:cNvPr id="4" name="Rounded Rectangle 3"/>
           <p:cNvSpPr/>
           <p:nvPr/>
         </p:nvSpPr>
@@ -14265,8 +14369,8 @@
             </a:avLst>
           </a:prstGeom>
           <a:solidFill>
-            <a:srgbClr val="FF4F9A">
-              <a:alpha val="80000"/>
+            <a:srgbClr val="D640A9">
+              <a:alpha val="54901"/>
             </a:srgbClr>
           </a:solidFill>
           <a:ln>
@@ -14298,7 +14402,7 @@
       </p:sp>
       <p:sp>
         <p:nvSpPr>
-          <p:cNvPr id="6" name="Rounded Rectangle 5"/>
+          <p:cNvPr id="5" name="Rounded Rectangle 4"/>
           <p:cNvSpPr/>
           <p:nvPr/>
         </p:nvSpPr>
@@ -14313,8 +14417,8 @@
             </a:avLst>
           </a:prstGeom>
           <a:solidFill>
-            <a:srgbClr val="FF4F9A">
-              <a:alpha val="80000"/>
+            <a:srgbClr val="D640A9">
+              <a:alpha val="54901"/>
             </a:srgbClr>
           </a:solidFill>
           <a:ln>
@@ -14346,7 +14450,7 @@
       </p:sp>
       <p:sp>
         <p:nvSpPr>
-          <p:cNvPr id="7" name="Rounded Rectangle 6"/>
+          <p:cNvPr id="6" name="Rounded Rectangle 5"/>
           <p:cNvSpPr/>
           <p:nvPr/>
         </p:nvSpPr>
@@ -14361,8 +14465,8 @@
             </a:avLst>
           </a:prstGeom>
           <a:solidFill>
-            <a:srgbClr val="FF4F9A">
-              <a:alpha val="80000"/>
+            <a:srgbClr val="D640A9">
+              <a:alpha val="54901"/>
             </a:srgbClr>
           </a:solidFill>
           <a:ln>
@@ -14394,7 +14498,7 @@
       </p:sp>
       <p:sp>
         <p:nvSpPr>
-          <p:cNvPr id="8" name="Rounded Rectangle 7"/>
+          <p:cNvPr id="7" name="Rounded Rectangle 6"/>
           <p:cNvSpPr/>
           <p:nvPr/>
         </p:nvSpPr>
@@ -14409,8 +14513,8 @@
             </a:avLst>
           </a:prstGeom>
           <a:solidFill>
-            <a:srgbClr val="FF4F9A">
-              <a:alpha val="80000"/>
+            <a:srgbClr val="D640A9">
+              <a:alpha val="54901"/>
             </a:srgbClr>
           </a:solidFill>
           <a:ln>
@@ -14442,7 +14546,7 @@
       </p:sp>
       <p:sp>
         <p:nvSpPr>
-          <p:cNvPr id="9" name="Rounded Rectangle 8"/>
+          <p:cNvPr id="8" name="Rounded Rectangle 7"/>
           <p:cNvSpPr/>
           <p:nvPr/>
         </p:nvSpPr>
@@ -14457,8 +14561,8 @@
             </a:avLst>
           </a:prstGeom>
           <a:solidFill>
-            <a:srgbClr val="FF4F9A">
-              <a:alpha val="80000"/>
+            <a:srgbClr val="D640A9">
+              <a:alpha val="54901"/>
             </a:srgbClr>
           </a:solidFill>
           <a:ln>
@@ -14490,7 +14594,7 @@
       </p:sp>
       <p:sp>
         <p:nvSpPr>
-          <p:cNvPr id="10" name="Rounded Rectangle 9"/>
+          <p:cNvPr id="9" name="Rounded Rectangle 8"/>
           <p:cNvSpPr/>
           <p:nvPr/>
         </p:nvSpPr>
@@ -14505,8 +14609,8 @@
             </a:avLst>
           </a:prstGeom>
           <a:solidFill>
-            <a:srgbClr val="FF4F9A">
-              <a:alpha val="80000"/>
+            <a:srgbClr val="D640A9">
+              <a:alpha val="54901"/>
             </a:srgbClr>
           </a:solidFill>
           <a:ln>
@@ -14538,7 +14642,7 @@
       </p:sp>
       <p:sp>
         <p:nvSpPr>
-          <p:cNvPr id="11" name="Rounded Rectangle 10"/>
+          <p:cNvPr id="10" name="Rounded Rectangle 9"/>
           <p:cNvSpPr/>
           <p:nvPr/>
         </p:nvSpPr>
@@ -14553,8 +14657,8 @@
             </a:avLst>
           </a:prstGeom>
           <a:solidFill>
-            <a:srgbClr val="FF4F9A">
-              <a:alpha val="80000"/>
+            <a:srgbClr val="D640A9">
+              <a:alpha val="54901"/>
             </a:srgbClr>
           </a:solidFill>
           <a:ln>
@@ -14586,7 +14690,7 @@
       </p:sp>
       <p:sp>
         <p:nvSpPr>
-          <p:cNvPr id="12" name="Rounded Rectangle 11"/>
+          <p:cNvPr id="11" name="Rounded Rectangle 10"/>
           <p:cNvSpPr/>
           <p:nvPr/>
         </p:nvSpPr>
@@ -14632,14 +14736,14 @@
       </p:sp>
       <p:sp>
         <p:nvSpPr>
-          <p:cNvPr id="13" name="TextBox 12"/>
+          <p:cNvPr id="12" name="TextBox 11"/>
           <p:cNvSpPr txBox="1"/>
           <p:nvPr/>
         </p:nvSpPr>
         <p:spPr>
           <a:xfrm>
             <a:off x="914400" y="2762250"/>
-            <a:ext cx="1685925" cy="323850"/>
+            <a:ext cx="1657350" cy="323850"/>
           </a:xfrm>
           <a:prstGeom prst="rect">
             <a:avLst/>
@@ -14656,18 +14760,18 @@
             <a:r>
               <a:rPr sz="3600" b="0" i="0">
                 <a:solidFill>
-                  <a:srgbClr val="F8F4FF"/>
+                  <a:srgbClr val="090711"/>
                 </a:solidFill>
                 <a:latin typeface="Roboto"/>
               </a:rPr>
-              <a:t>GYEOL</a:t>
-            </a:r>
-          </a:p>
-        </p:txBody>
-      </p:sp>
-      <p:sp>
-        <p:nvSpPr>
-          <p:cNvPr id="14" name="TextBox 13"/>
+              <a:t>PULSE</a:t>
+            </a:r>
+          </a:p>
+        </p:txBody>
+      </p:sp>
+      <p:sp>
+        <p:nvSpPr>
+          <p:cNvPr id="13" name="TextBox 12"/>
           <p:cNvSpPr txBox="1"/>
           <p:nvPr/>
         </p:nvSpPr>
@@ -14691,7 +14795,7 @@
             <a:r>
               <a:rPr sz="3600" b="0" i="0">
                 <a:solidFill>
-                  <a:srgbClr val="C7BDD9"/>
+                  <a:srgbClr val="090711"/>
                 </a:solidFill>
                 <a:latin typeface="Pretendard"/>
               </a:rPr>
@@ -14702,14 +14806,14 @@
       </p:sp>
       <p:sp>
         <p:nvSpPr>
-          <p:cNvPr id="15" name="TextBox 14"/>
+          <p:cNvPr id="14" name="TextBox 13"/>
           <p:cNvSpPr txBox="1"/>
           <p:nvPr/>
         </p:nvSpPr>
         <p:spPr>
           <a:xfrm>
             <a:off x="914400" y="3905250"/>
-            <a:ext cx="5476875" cy="323850"/>
+            <a:ext cx="5400675" cy="323850"/>
           </a:xfrm>
           <a:prstGeom prst="rect">
             <a:avLst/>
@@ -14730,25 +14834,25 @@
             <a:r>
               <a:rPr sz="3600" b="0" i="0">
                 <a:solidFill>
-                  <a:srgbClr val="FF4F9A"/>
+                  <a:srgbClr val="090711"/>
                 </a:solidFill>
                 <a:latin typeface="Pretendard"/>
               </a:rPr>
-              <a:t>GYEOL · START TODAY</a:t>
-            </a:r>
-          </a:p>
-        </p:txBody>
-      </p:sp>
-      <p:sp>
-        <p:nvSpPr>
-          <p:cNvPr id="16" name="TextBox 15"/>
+              <a:t>PULSE · START TODAY</a:t>
+            </a:r>
+          </a:p>
+        </p:txBody>
+      </p:sp>
+      <p:sp>
+        <p:nvSpPr>
+          <p:cNvPr id="15" name="TextBox 14"/>
           <p:cNvSpPr txBox="1"/>
           <p:nvPr/>
         </p:nvSpPr>
         <p:spPr>
           <a:xfrm>
             <a:off x="914400" y="4762500"/>
-            <a:ext cx="7191375" cy="2209800"/>
+            <a:ext cx="4667250" cy="1990725"/>
           </a:xfrm>
           <a:prstGeom prst="rect">
             <a:avLst/>
@@ -14769,11 +14873,11 @@
             <a:r>
               <a:rPr sz="9300" b="0" i="0">
                 <a:solidFill>
-                  <a:srgbClr val="FFFFFF"/>
+                  <a:srgbClr val="090711"/>
                 </a:solidFill>
                 <a:latin typeface="Pretendard"/>
               </a:rPr>
-              <a:t>오늘, 다시 시작</a:t>
+              <a:t>TIME TO</a:t>
             </a:r>
           </a:p>
           <a:p>
@@ -14785,25 +14889,25 @@
             <a:r>
               <a:rPr sz="9300" b="0" i="0">
                 <a:solidFill>
-                  <a:srgbClr val="FFFFFF"/>
+                  <a:srgbClr val="090711"/>
                 </a:solidFill>
                 <a:latin typeface="Pretendard"/>
               </a:rPr>
-              <a:t>나답게 움직이기</a:t>
-            </a:r>
-          </a:p>
-        </p:txBody>
-      </p:sp>
-      <p:sp>
-        <p:nvSpPr>
-          <p:cNvPr id="17" name="TextBox 16"/>
+              <a:t>MOVE.</a:t>
+            </a:r>
+          </a:p>
+        </p:txBody>
+      </p:sp>
+      <p:sp>
+        <p:nvSpPr>
+          <p:cNvPr id="16" name="TextBox 15"/>
           <p:cNvSpPr txBox="1"/>
           <p:nvPr/>
         </p:nvSpPr>
         <p:spPr>
           <a:xfrm>
             <a:off x="914400" y="7667625"/>
-            <a:ext cx="6743700" cy="447675"/>
+            <a:ext cx="6858000" cy="1047750"/>
           </a:xfrm>
           <a:prstGeom prst="rect">
             <a:avLst/>
@@ -14824,18 +14928,34 @@
             <a:r>
               <a:rPr sz="3900" b="0" i="0">
                 <a:solidFill>
-                  <a:srgbClr val="C7BDD9"/>
+                  <a:srgbClr val="32112F"/>
                 </a:solidFill>
                 <a:latin typeface="Pretendard"/>
               </a:rPr>
-              <a:t>내 몸을 이해하는 가장 선명한 방법.</a:t>
-            </a:r>
-          </a:p>
-        </p:txBody>
-      </p:sp>
-      <p:sp>
-        <p:nvSpPr>
-          <p:cNvPr id="18" name="Rounded Rectangle 17"/>
+              <a:t>The fastest way to understand</a:t>
+            </a:r>
+          </a:p>
+          <a:p>
+            <a:pPr algn="l">
+              <a:lnSpc>
+                <a:spcPts val="4725"/>
+              </a:lnSpc>
+            </a:pPr>
+            <a:r>
+              <a:rPr sz="3900" b="0" i="0">
+                <a:solidFill>
+                  <a:srgbClr val="32112F"/>
+                </a:solidFill>
+                <a:latin typeface="Pretendard"/>
+              </a:rPr>
+              <a:t>your body.</a:t>
+            </a:r>
+          </a:p>
+        </p:txBody>
+      </p:sp>
+      <p:sp>
+        <p:nvSpPr>
+          <p:cNvPr id="17" name="Rounded Rectangle 16"/>
           <p:cNvSpPr/>
           <p:nvPr/>
         </p:nvSpPr>
@@ -14850,7 +14970,7 @@
             </a:avLst>
           </a:prstGeom>
           <a:solidFill>
-            <a:srgbClr val="FF4F9A"/>
+            <a:srgbClr val="090711"/>
           </a:solidFill>
           <a:ln>
             <a:noFill/>
@@ -14892,14 +15012,14 @@
       </p:sp>
       <p:sp>
         <p:nvSpPr>
-          <p:cNvPr id="19" name="TextBox 18"/>
+          <p:cNvPr id="18" name="TextBox 17"/>
           <p:cNvSpPr txBox="1"/>
           <p:nvPr/>
         </p:nvSpPr>
         <p:spPr>
           <a:xfrm>
-            <a:off x="3057525" y="10010775"/>
-            <a:ext cx="3324225" cy="485775"/>
+            <a:off x="3124200" y="10058400"/>
+            <a:ext cx="3190875" cy="390525"/>
           </a:xfrm>
           <a:prstGeom prst="rect">
             <a:avLst/>
@@ -14920,21 +15040,21 @@
                 </a:solidFill>
                 <a:latin typeface="Pretendard"/>
               </a:rPr>
-              <a:t>무료로 시작하기</a:t>
-            </a:r>
-          </a:p>
-        </p:txBody>
-      </p:sp>
-      <p:sp>
-        <p:nvSpPr>
-          <p:cNvPr id="20" name="TextBox 19"/>
+              <a:t>START FREE</a:t>
+            </a:r>
+          </a:p>
+        </p:txBody>
+      </p:sp>
+      <p:sp>
+        <p:nvSpPr>
+          <p:cNvPr id="19" name="TextBox 18"/>
           <p:cNvSpPr txBox="1"/>
           <p:nvPr/>
         </p:nvSpPr>
         <p:spPr>
           <a:xfrm>
             <a:off x="914400" y="11620500"/>
-            <a:ext cx="5905500" cy="419100"/>
+            <a:ext cx="5943600" cy="819150"/>
           </a:xfrm>
           <a:prstGeom prst="rect">
             <a:avLst/>
@@ -14955,25 +15075,41 @@
             <a:r>
               <a:rPr sz="3600" b="0" i="0">
                 <a:solidFill>
-                  <a:srgbClr val="F8F4FF"/>
+                  <a:srgbClr val="090711"/>
                 </a:solidFill>
                 <a:latin typeface="Pretendard"/>
               </a:rPr>
-              <a:t>평점 4.9 · 7일 무료 · 언제든 해지</a:t>
-            </a:r>
-          </a:p>
-        </p:txBody>
-      </p:sp>
-      <p:sp>
-        <p:nvSpPr>
-          <p:cNvPr id="21" name="TextBox 20"/>
+              <a:t>4.9 RATING · 7 DAYS FREE ·</a:t>
+            </a:r>
+          </a:p>
+          <a:p>
+            <a:pPr algn="l">
+              <a:lnSpc>
+                <a:spcPts val="3900"/>
+              </a:lnSpc>
+            </a:pPr>
+            <a:r>
+              <a:rPr sz="3600" b="0" i="0">
+                <a:solidFill>
+                  <a:srgbClr val="090711"/>
+                </a:solidFill>
+                <a:latin typeface="Pretendard"/>
+              </a:rPr>
+              <a:t>CANCEL ANYTIME</a:t>
+            </a:r>
+          </a:p>
+        </p:txBody>
+      </p:sp>
+      <p:sp>
+        <p:nvSpPr>
+          <p:cNvPr id="20" name="TextBox 19"/>
           <p:cNvSpPr txBox="1"/>
           <p:nvPr/>
         </p:nvSpPr>
         <p:spPr>
           <a:xfrm>
             <a:off x="914400" y="13811250"/>
-            <a:ext cx="3876675" cy="381000"/>
+            <a:ext cx="3771900" cy="381000"/>
           </a:xfrm>
           <a:prstGeom prst="rect">
             <a:avLst/>
@@ -14990,11 +15126,11 @@
             <a:r>
               <a:rPr sz="4050" b="0" i="0">
                 <a:solidFill>
-                  <a:srgbClr val="F8F4FF"/>
+                  <a:srgbClr val="090711"/>
                 </a:solidFill>
                 <a:latin typeface="Pretendard"/>
               </a:rPr>
-              <a:t>GYEOL.APP  ↗</a:t>
+              <a:t>PULSE.APP  ↗</a:t>
             </a:r>
           </a:p>
         </p:txBody>
@@ -15041,7 +15177,7 @@
                                           </p:stCondLst>
                                         </p:cTn>
                                         <p:tgtEl>
-                                          <p:spTgt spid="15"/>
+                                          <p:spTgt spid="14"/>
                                         </p:tgtEl>
                                         <p:attrNameLst>
                                           <p:attrName>style.visibility</p:attrName>
@@ -15055,7 +15191,7 @@
                                       <p:cBhvr>
                                         <p:cTn id="15" dur="281"/>
                                         <p:tgtEl>
-                                          <p:spTgt spid="15"/>
+                                          <p:spTgt spid="14"/>
                                         </p:tgtEl>
                                       </p:cBhvr>
                                     </p:animEffect>
@@ -15076,7 +15212,7 @@
                                           </p:stCondLst>
                                         </p:cTn>
                                         <p:tgtEl>
-                                          <p:spTgt spid="16"/>
+                                          <p:spTgt spid="15"/>
                                         </p:tgtEl>
                                         <p:attrNameLst>
                                           <p:attrName>style.visibility</p:attrName>
@@ -15090,7 +15226,7 @@
                                       <p:cBhvr>
                                         <p:cTn id="18" dur="422"/>
                                         <p:tgtEl>
-                                          <p:spTgt spid="16"/>
+                                          <p:spTgt spid="15"/>
                                         </p:tgtEl>
                                       </p:cBhvr>
                                     </p:animEffect>
@@ -15111,7 +15247,7 @@
                                           </p:stCondLst>
                                         </p:cTn>
                                         <p:tgtEl>
-                                          <p:spTgt spid="17"/>
+                                          <p:spTgt spid="16"/>
                                         </p:tgtEl>
                                         <p:attrNameLst>
                                           <p:attrName>style.visibility</p:attrName>
@@ -15125,7 +15261,7 @@
                                       <p:cBhvr>
                                         <p:cTn id="21" dur="281"/>
                                         <p:tgtEl>
-                                          <p:spTgt spid="17"/>
+                                          <p:spTgt spid="16"/>
                                         </p:tgtEl>
                                       </p:cBhvr>
                                     </p:animEffect>
@@ -15146,7 +15282,7 @@
                                           </p:stCondLst>
                                         </p:cTn>
                                         <p:tgtEl>
-                                          <p:spTgt spid="18"/>
+                                          <p:spTgt spid="17"/>
                                         </p:tgtEl>
                                         <p:attrNameLst>
                                           <p:attrName>style.visibility</p:attrName>
@@ -15160,7 +15296,7 @@
                                       <p:cBhvr>
                                         <p:cTn id="24" dur="375"/>
                                         <p:tgtEl>
-                                          <p:spTgt spid="18"/>
+                                          <p:spTgt spid="17"/>
                                         </p:tgtEl>
                                       </p:cBhvr>
                                     </p:animEffect>
@@ -15181,7 +15317,7 @@
                                           </p:stCondLst>
                                         </p:cTn>
                                         <p:tgtEl>
-                                          <p:spTgt spid="19"/>
+                                          <p:spTgt spid="18"/>
                                         </p:tgtEl>
                                         <p:attrNameLst>
                                           <p:attrName>style.visibility</p:attrName>
@@ -15195,7 +15331,7 @@
                                       <p:cBhvr>
                                         <p:cTn id="27" dur="281"/>
                                         <p:tgtEl>
-                                          <p:spTgt spid="19"/>
+                                          <p:spTgt spid="18"/>
                                         </p:tgtEl>
                                       </p:cBhvr>
                                     </p:animEffect>
@@ -15216,7 +15352,7 @@
                                           </p:stCondLst>
                                         </p:cTn>
                                         <p:tgtEl>
-                                          <p:spTgt spid="20"/>
+                                          <p:spTgt spid="19"/>
                                         </p:tgtEl>
                                         <p:attrNameLst>
                                           <p:attrName>style.visibility</p:attrName>
@@ -15230,7 +15366,7 @@
                                       <p:cBhvr>
                                         <p:cTn id="30" dur="281"/>
                                         <p:tgtEl>
-                                          <p:spTgt spid="20"/>
+                                          <p:spTgt spid="19"/>
                                         </p:tgtEl>
                                       </p:cBhvr>
                                     </p:animEffect>
@@ -15251,7 +15387,7 @@
                                           </p:stCondLst>
                                         </p:cTn>
                                         <p:tgtEl>
-                                          <p:spTgt spid="21"/>
+                                          <p:spTgt spid="20"/>
                                         </p:tgtEl>
                                         <p:attrNameLst>
                                           <p:attrName>style.visibility</p:attrName>
@@ -15265,7 +15401,7 @@
                                       <p:cBhvr>
                                         <p:cTn id="33" dur="281"/>
                                         <p:tgtEl>
-                                          <p:spTgt spid="21"/>
+                                          <p:spTgt spid="20"/>
                                         </p:tgtEl>
                                       </p:cBhvr>
                                     </p:animEffect>
@@ -15309,7 +15445,7 @@
                         </p:stCondLst>
                       </p:cTn>
                       <p:tgtEl>
-                        <p:spTgt spid="15"/>
+                        <p:spTgt spid="14"/>
                       </p:tgtEl>
                       <p:attrNameLst>
                         <p:attrName>style.visibility</p:attrName>
@@ -15327,7 +15463,7 @@
                         </p:stCondLst>
                       </p:cTn>
                       <p:tgtEl>
-                        <p:spTgt spid="16"/>
+                        <p:spTgt spid="15"/>
                       </p:tgtEl>
                       <p:attrNameLst>
                         <p:attrName>style.visibility</p:attrName>
@@ -15345,7 +15481,7 @@
                         </p:stCondLst>
                       </p:cTn>
                       <p:tgtEl>
-                        <p:spTgt spid="17"/>
+                        <p:spTgt spid="16"/>
                       </p:tgtEl>
                       <p:attrNameLst>
                         <p:attrName>style.visibility</p:attrName>
@@ -15363,7 +15499,7 @@
                         </p:stCondLst>
                       </p:cTn>
                       <p:tgtEl>
-                        <p:spTgt spid="18"/>
+                        <p:spTgt spid="17"/>
                       </p:tgtEl>
                       <p:attrNameLst>
                         <p:attrName>style.visibility</p:attrName>
@@ -15381,7 +15517,7 @@
                         </p:stCondLst>
                       </p:cTn>
                       <p:tgtEl>
-                        <p:spTgt spid="19"/>
+                        <p:spTgt spid="18"/>
                       </p:tgtEl>
                       <p:attrNameLst>
                         <p:attrName>style.visibility</p:attrName>
@@ -15399,7 +15535,7 @@
                         </p:stCondLst>
                       </p:cTn>
                       <p:tgtEl>
-                        <p:spTgt spid="20"/>
+                        <p:spTgt spid="19"/>
                       </p:tgtEl>
                       <p:attrNameLst>
                         <p:attrName>style.visibility</p:attrName>
@@ -15417,7 +15553,7 @@
                         </p:stCondLst>
                       </p:cTn>
                       <p:tgtEl>
-                        <p:spTgt spid="21"/>
+                        <p:spTgt spid="20"/>
                       </p:tgtEl>
                       <p:attrNameLst>
                         <p:attrName>style.visibility</p:attrName>

</xml_diff>